<commit_message>
fix(presentation): all text 20pt, strip --- and ** markers
</commit_message>
<xml_diff>
--- a/presentation/talk.pptx
+++ b/presentation/talk.pptx
@@ -3139,7 +3139,7 @@
           <a:lstStyle/>
           <a:p>
             <a:pPr>
-              <a:defRPr sz="2200" b="1">
+              <a:defRPr sz="2000" b="1">
                 <a:solidFill>
                   <a:srgbClr val="1F2D5A"/>
                 </a:solidFill>
@@ -3174,7 +3174,7 @@
           <a:lstStyle/>
           <a:p>
             <a:pPr>
-              <a:defRPr sz="1300">
+              <a:defRPr sz="2000">
                 <a:solidFill>
                   <a:srgbClr val="202020"/>
                 </a:solidFill>
@@ -3186,16 +3186,16 @@
           </a:p>
           <a:p>
             <a:pPr>
-              <a:defRPr sz="1300">
-                <a:solidFill>
-                  <a:srgbClr val="202020"/>
-                </a:solidFill>
-              </a:defRPr>
-            </a:pPr>
-          </a:p>
-          <a:p>
-            <a:pPr>
-              <a:defRPr sz="1300">
+              <a:defRPr sz="2000">
+                <a:solidFill>
+                  <a:srgbClr val="202020"/>
+                </a:solidFill>
+              </a:defRPr>
+            </a:pPr>
+          </a:p>
+          <a:p>
+            <a:pPr>
+              <a:defRPr sz="2000">
                 <a:solidFill>
                   <a:srgbClr val="202020"/>
                 </a:solidFill>
@@ -3207,16 +3207,16 @@
           </a:p>
           <a:p>
             <a:pPr>
-              <a:defRPr sz="1300">
-                <a:solidFill>
-                  <a:srgbClr val="202020"/>
-                </a:solidFill>
-              </a:defRPr>
-            </a:pPr>
-          </a:p>
-          <a:p>
-            <a:pPr>
-              <a:defRPr sz="1300">
+              <a:defRPr sz="2000">
+                <a:solidFill>
+                  <a:srgbClr val="202020"/>
+                </a:solidFill>
+              </a:defRPr>
+            </a:pPr>
+          </a:p>
+          <a:p>
+            <a:pPr>
+              <a:defRPr sz="2000">
                 <a:solidFill>
                   <a:srgbClr val="202020"/>
                 </a:solidFill>
@@ -3224,27 +3224,6 @@
             </a:pPr>
             <a:r>
               <a:t>来源：`20251219_dmi_fm/successful_simulation/run_analytic_relax.out/`</a:t>
-            </a:r>
-          </a:p>
-          <a:p>
-            <a:pPr>
-              <a:defRPr sz="1300">
-                <a:solidFill>
-                  <a:srgbClr val="202020"/>
-                </a:solidFill>
-              </a:defRPr>
-            </a:pPr>
-          </a:p>
-          <a:p>
-            <a:pPr>
-              <a:defRPr sz="1300">
-                <a:solidFill>
-                  <a:srgbClr val="202020"/>
-                </a:solidFill>
-              </a:defRPr>
-            </a:pPr>
-            <a:r>
-              <a:t>---</a:t>
             </a:r>
           </a:p>
         </p:txBody>
@@ -3314,7 +3293,7 @@
           <a:lstStyle/>
           <a:p>
             <a:pPr>
-              <a:defRPr sz="2200" b="1">
+              <a:defRPr sz="2000" b="1">
                 <a:solidFill>
                   <a:srgbClr val="1F2D5A"/>
                 </a:solidFill>
@@ -3349,7 +3328,7 @@
           <a:lstStyle/>
           <a:p>
             <a:pPr>
-              <a:defRPr sz="1300">
+              <a:defRPr sz="2000">
                 <a:solidFill>
                   <a:srgbClr val="202020"/>
                 </a:solidFill>
@@ -3361,7 +3340,7 @@
           </a:p>
           <a:p>
             <a:pPr>
-              <a:defRPr sz="1300">
+              <a:defRPr sz="2000">
                 <a:solidFill>
                   <a:srgbClr val="202020"/>
                 </a:solidFill>
@@ -3373,7 +3352,7 @@
           </a:p>
           <a:p>
             <a:pPr>
-              <a:defRPr sz="1300">
+              <a:defRPr sz="2000">
                 <a:solidFill>
                   <a:srgbClr val="202020"/>
                 </a:solidFill>
@@ -3385,37 +3364,37 @@
           </a:p>
           <a:p>
             <a:pPr>
-              <a:defRPr sz="1300">
-                <a:solidFill>
-                  <a:srgbClr val="202020"/>
-                </a:solidFill>
-              </a:defRPr>
-            </a:pPr>
-          </a:p>
-          <a:p>
-            <a:pPr>
-              <a:defRPr sz="1300">
-                <a:solidFill>
-                  <a:srgbClr val="202020"/>
-                </a:solidFill>
-              </a:defRPr>
-            </a:pPr>
-            <a:r>
-              <a:t>**当初结论**：bg=mz 漂移、bg=mx,my 稳定。该结论已写入毕设论文 ch03 §3.2.3 早期版本。</a:t>
-            </a:r>
-          </a:p>
-          <a:p>
-            <a:pPr>
-              <a:defRPr sz="1300">
-                <a:solidFill>
-                  <a:srgbClr val="202020"/>
-                </a:solidFill>
-              </a:defRPr>
-            </a:pPr>
-          </a:p>
-          <a:p>
-            <a:pPr>
-              <a:defRPr sz="1300">
+              <a:defRPr sz="2000">
+                <a:solidFill>
+                  <a:srgbClr val="202020"/>
+                </a:solidFill>
+              </a:defRPr>
+            </a:pPr>
+          </a:p>
+          <a:p>
+            <a:pPr>
+              <a:defRPr sz="2000">
+                <a:solidFill>
+                  <a:srgbClr val="202020"/>
+                </a:solidFill>
+              </a:defRPr>
+            </a:pPr>
+            <a:r>
+              <a:t>当初结论：bg=mz 漂移、bg=mx,my 稳定。该结论已写入毕设论文 ch03 §3.2.3 早期版本。</a:t>
+            </a:r>
+          </a:p>
+          <a:p>
+            <a:pPr>
+              <a:defRPr sz="2000">
+                <a:solidFill>
+                  <a:srgbClr val="202020"/>
+                </a:solidFill>
+              </a:defRPr>
+            </a:pPr>
+          </a:p>
+          <a:p>
+            <a:pPr>
+              <a:defRPr sz="2000">
                 <a:solidFill>
                   <a:srgbClr val="202020"/>
                 </a:solidFill>
@@ -3423,27 +3402,6 @@
             </a:pPr>
             <a:r>
               <a:t>无图。来源：`20260105_frustrated_fm/drift_experiments/{bg_mx_axis_x_stable, bg_my_axis_y_stable}/`</a:t>
-            </a:r>
-          </a:p>
-          <a:p>
-            <a:pPr>
-              <a:defRPr sz="1300">
-                <a:solidFill>
-                  <a:srgbClr val="202020"/>
-                </a:solidFill>
-              </a:defRPr>
-            </a:pPr>
-          </a:p>
-          <a:p>
-            <a:pPr>
-              <a:defRPr sz="1300">
-                <a:solidFill>
-                  <a:srgbClr val="202020"/>
-                </a:solidFill>
-              </a:defRPr>
-            </a:pPr>
-            <a:r>
-              <a:t>---</a:t>
             </a:r>
           </a:p>
         </p:txBody>
@@ -3489,7 +3447,7 @@
           <a:lstStyle/>
           <a:p>
             <a:pPr>
-              <a:defRPr sz="2200" b="1">
+              <a:defRPr sz="2000" b="1">
                 <a:solidFill>
                   <a:srgbClr val="1F2D5A"/>
                 </a:solidFill>
@@ -3524,7 +3482,7 @@
           <a:lstStyle/>
           <a:p>
             <a:pPr>
-              <a:defRPr sz="1300">
+              <a:defRPr sz="2000">
                 <a:solidFill>
                   <a:srgbClr val="202020"/>
                 </a:solidFill>
@@ -3536,58 +3494,58 @@
           </a:p>
           <a:p>
             <a:pPr>
-              <a:defRPr sz="1300">
-                <a:solidFill>
-                  <a:srgbClr val="202020"/>
-                </a:solidFill>
-              </a:defRPr>
-            </a:pPr>
-          </a:p>
-          <a:p>
-            <a:pPr>
-              <a:defRPr sz="1300">
-                <a:solidFill>
-                  <a:srgbClr val="202020"/>
-                </a:solidFill>
-              </a:defRPr>
-            </a:pPr>
-            <a:r>
-              <a:t>**结果**：4 组完全一致，bg 方向无影响。**旧结论推翻。**</a:t>
-            </a:r>
-          </a:p>
-          <a:p>
-            <a:pPr>
-              <a:defRPr sz="1300">
-                <a:solidFill>
-                  <a:srgbClr val="202020"/>
-                </a:solidFill>
-              </a:defRPr>
-            </a:pPr>
-          </a:p>
-          <a:p>
-            <a:pPr>
-              <a:defRPr sz="1300">
-                <a:solidFill>
-                  <a:srgbClr val="202020"/>
-                </a:solidFill>
-              </a:defRPr>
-            </a:pPr>
-            <a:r>
-              <a:t>**真实机理**：前 1 ns 轴向格点递举弛豫 4.75 nm，之后钉扎。漂移与背景磁化方向无关。</a:t>
-            </a:r>
-          </a:p>
-          <a:p>
-            <a:pPr>
-              <a:defRPr sz="1300">
-                <a:solidFill>
-                  <a:srgbClr val="202020"/>
-                </a:solidFill>
-              </a:defRPr>
-            </a:pPr>
-          </a:p>
-          <a:p>
-            <a:pPr>
-              <a:defRPr sz="1300">
+              <a:defRPr sz="2000">
+                <a:solidFill>
+                  <a:srgbClr val="202020"/>
+                </a:solidFill>
+              </a:defRPr>
+            </a:pPr>
+          </a:p>
+          <a:p>
+            <a:pPr>
+              <a:defRPr sz="2000">
+                <a:solidFill>
+                  <a:srgbClr val="202020"/>
+                </a:solidFill>
+              </a:defRPr>
+            </a:pPr>
+            <a:r>
+              <a:t>结果：4 组完全一致，bg 方向无影响。旧结论推翻。</a:t>
+            </a:r>
+          </a:p>
+          <a:p>
+            <a:pPr>
+              <a:defRPr sz="2000">
+                <a:solidFill>
+                  <a:srgbClr val="202020"/>
+                </a:solidFill>
+              </a:defRPr>
+            </a:pPr>
+          </a:p>
+          <a:p>
+            <a:pPr>
+              <a:defRPr sz="2000">
+                <a:solidFill>
+                  <a:srgbClr val="202020"/>
+                </a:solidFill>
+              </a:defRPr>
+            </a:pPr>
+            <a:r>
+              <a:t>真实机理：前 1 ns 轴向格点递举弛豫 4.75 nm，之后钉扎。漂移与背景磁化方向无关。</a:t>
+            </a:r>
+          </a:p>
+          <a:p>
+            <a:pPr>
+              <a:defRPr sz="2000">
+                <a:solidFill>
+                  <a:srgbClr val="202020"/>
+                </a:solidFill>
+              </a:defRPr>
+            </a:pPr>
+          </a:p>
+          <a:p>
+            <a:pPr>
+              <a:defRPr sz="2000">
                 <a:solidFill>
                   <a:srgbClr val="202020"/>
                 </a:solidFill>
@@ -3599,16 +3557,16 @@
           </a:p>
           <a:p>
             <a:pPr>
-              <a:defRPr sz="1300">
-                <a:solidFill>
-                  <a:srgbClr val="202020"/>
-                </a:solidFill>
-              </a:defRPr>
-            </a:pPr>
-          </a:p>
-          <a:p>
-            <a:pPr>
-              <a:defRPr sz="1300">
+              <a:defRPr sz="2000">
+                <a:solidFill>
+                  <a:srgbClr val="202020"/>
+                </a:solidFill>
+              </a:defRPr>
+            </a:pPr>
+          </a:p>
+          <a:p>
+            <a:pPr>
+              <a:defRPr sz="2000">
                 <a:solidFill>
                   <a:srgbClr val="202020"/>
                 </a:solidFill>
@@ -3616,27 +3574,6 @@
             </a:pPr>
             <a:r>
               <a:t>来源：`20260105_frustrated_fm/drift_experiments/unified_rerun/`（4 组 + continue）</a:t>
-            </a:r>
-          </a:p>
-          <a:p>
-            <a:pPr>
-              <a:defRPr sz="1300">
-                <a:solidFill>
-                  <a:srgbClr val="202020"/>
-                </a:solidFill>
-              </a:defRPr>
-            </a:pPr>
-          </a:p>
-          <a:p>
-            <a:pPr>
-              <a:defRPr sz="1300">
-                <a:solidFill>
-                  <a:srgbClr val="202020"/>
-                </a:solidFill>
-              </a:defRPr>
-            </a:pPr>
-            <a:r>
-              <a:t>---</a:t>
             </a:r>
           </a:p>
         </p:txBody>
@@ -3706,7 +3643,7 @@
           <a:lstStyle/>
           <a:p>
             <a:pPr>
-              <a:defRPr sz="2200" b="1">
+              <a:defRPr sz="2000" b="1">
                 <a:solidFill>
                   <a:srgbClr val="1F2D5A"/>
                 </a:solidFill>
@@ -3741,7 +3678,7 @@
           <a:lstStyle/>
           <a:p>
             <a:pPr>
-              <a:defRPr sz="1300">
+              <a:defRPr sz="2000">
                 <a:solidFill>
                   <a:srgbClr val="202020"/>
                 </a:solidFill>
@@ -3753,28 +3690,28 @@
           </a:p>
           <a:p>
             <a:pPr>
-              <a:defRPr sz="1300">
-                <a:solidFill>
-                  <a:srgbClr val="202020"/>
-                </a:solidFill>
-              </a:defRPr>
-            </a:pPr>
-          </a:p>
-          <a:p>
-            <a:pPr>
-              <a:defRPr sz="1300">
-                <a:solidFill>
-                  <a:srgbClr val="202020"/>
-                </a:solidFill>
-              </a:defRPr>
-            </a:pPr>
-            <a:r>
-              <a:t>**结论**：</a:t>
-            </a:r>
-          </a:p>
-          <a:p>
-            <a:pPr>
-              <a:defRPr sz="1300">
+              <a:defRPr sz="2000">
+                <a:solidFill>
+                  <a:srgbClr val="202020"/>
+                </a:solidFill>
+              </a:defRPr>
+            </a:pPr>
+          </a:p>
+          <a:p>
+            <a:pPr>
+              <a:defRPr sz="2000">
+                <a:solidFill>
+                  <a:srgbClr val="202020"/>
+                </a:solidFill>
+              </a:defRPr>
+            </a:pPr>
+            <a:r>
+              <a:t>结论：</a:t>
+            </a:r>
+          </a:p>
+          <a:p>
+            <a:pPr>
+              <a:defRPr sz="2000">
                 <a:solidFill>
                   <a:srgbClr val="202020"/>
                 </a:solidFill>
@@ -3786,7 +3723,7 @@
           </a:p>
           <a:p>
             <a:pPr>
-              <a:defRPr sz="1300">
+              <a:defRPr sz="2000">
                 <a:solidFill>
                   <a:srgbClr val="202020"/>
                 </a:solidFill>
@@ -3798,7 +3735,7 @@
           </a:p>
           <a:p>
             <a:pPr>
-              <a:defRPr sz="1300">
+              <a:defRPr sz="2000">
                 <a:solidFill>
                   <a:srgbClr val="202020"/>
                 </a:solidFill>
@@ -3810,16 +3747,16 @@
           </a:p>
           <a:p>
             <a:pPr>
-              <a:defRPr sz="1300">
-                <a:solidFill>
-                  <a:srgbClr val="202020"/>
-                </a:solidFill>
-              </a:defRPr>
-            </a:pPr>
-          </a:p>
-          <a:p>
-            <a:pPr>
-              <a:defRPr sz="1300">
+              <a:defRPr sz="2000">
+                <a:solidFill>
+                  <a:srgbClr val="202020"/>
+                </a:solidFill>
+              </a:defRPr>
+            </a:pPr>
+          </a:p>
+          <a:p>
+            <a:pPr>
+              <a:defRPr sz="2000">
                 <a:solidFill>
                   <a:srgbClr val="202020"/>
                 </a:solidFill>
@@ -3831,16 +3768,16 @@
           </a:p>
           <a:p>
             <a:pPr>
-              <a:defRPr sz="1300">
-                <a:solidFill>
-                  <a:srgbClr val="202020"/>
-                </a:solidFill>
-              </a:defRPr>
-            </a:pPr>
-          </a:p>
-          <a:p>
-            <a:pPr>
-              <a:defRPr sz="1300">
+              <a:defRPr sz="2000">
+                <a:solidFill>
+                  <a:srgbClr val="202020"/>
+                </a:solidFill>
+              </a:defRPr>
+            </a:pPr>
+          </a:p>
+          <a:p>
+            <a:pPr>
+              <a:defRPr sz="2000">
                 <a:solidFill>
                   <a:srgbClr val="202020"/>
                 </a:solidFill>
@@ -3848,27 +3785,6 @@
             </a:pPr>
             <a:r>
               <a:t>来源：`20260105_frustrated_fm/spin_wave_dynamics/drive_selection/plane_wave/`</a:t>
-            </a:r>
-          </a:p>
-          <a:p>
-            <a:pPr>
-              <a:defRPr sz="1300">
-                <a:solidFill>
-                  <a:srgbClr val="202020"/>
-                </a:solidFill>
-              </a:defRPr>
-            </a:pPr>
-          </a:p>
-          <a:p>
-            <a:pPr>
-              <a:defRPr sz="1300">
-                <a:solidFill>
-                  <a:srgbClr val="202020"/>
-                </a:solidFill>
-              </a:defRPr>
-            </a:pPr>
-            <a:r>
-              <a:t>---</a:t>
             </a:r>
           </a:p>
         </p:txBody>
@@ -3938,7 +3854,7 @@
           <a:lstStyle/>
           <a:p>
             <a:pPr>
-              <a:defRPr sz="2200" b="1">
+              <a:defRPr sz="2000" b="1">
                 <a:solidFill>
                   <a:srgbClr val="1F2D5A"/>
                 </a:solidFill>
@@ -3973,7 +3889,7 @@
           <a:lstStyle/>
           <a:p>
             <a:pPr>
-              <a:defRPr sz="1300">
+              <a:defRPr sz="2000">
                 <a:solidFill>
                   <a:srgbClr val="202020"/>
                 </a:solidFill>
@@ -3985,37 +3901,37 @@
           </a:p>
           <a:p>
             <a:pPr>
-              <a:defRPr sz="1300">
-                <a:solidFill>
-                  <a:srgbClr val="202020"/>
-                </a:solidFill>
-              </a:defRPr>
-            </a:pPr>
-          </a:p>
-          <a:p>
-            <a:pPr>
-              <a:defRPr sz="1300">
-                <a:solidFill>
-                  <a:srgbClr val="202020"/>
-                </a:solidFill>
-              </a:defRPr>
-            </a:pPr>
-            <a:r>
-              <a:t>**结论**：100-200 GHz、1000 GHz 强响应；400-600 GHz 死区（位移近零）；Hopfion 沿 +z 方向运动（垂直波传播方向）。</a:t>
-            </a:r>
-          </a:p>
-          <a:p>
-            <a:pPr>
-              <a:defRPr sz="1300">
-                <a:solidFill>
-                  <a:srgbClr val="202020"/>
-                </a:solidFill>
-              </a:defRPr>
-            </a:pPr>
-          </a:p>
-          <a:p>
-            <a:pPr>
-              <a:defRPr sz="1300">
+              <a:defRPr sz="2000">
+                <a:solidFill>
+                  <a:srgbClr val="202020"/>
+                </a:solidFill>
+              </a:defRPr>
+            </a:pPr>
+          </a:p>
+          <a:p>
+            <a:pPr>
+              <a:defRPr sz="2000">
+                <a:solidFill>
+                  <a:srgbClr val="202020"/>
+                </a:solidFill>
+              </a:defRPr>
+            </a:pPr>
+            <a:r>
+              <a:t>结论：100-200 GHz、1000 GHz 强响应；400-600 GHz 死区（位移近零）；Hopfion 沿 +z 方向运动（垂直波传播方向）。</a:t>
+            </a:r>
+          </a:p>
+          <a:p>
+            <a:pPr>
+              <a:defRPr sz="2000">
+                <a:solidFill>
+                  <a:srgbClr val="202020"/>
+                </a:solidFill>
+              </a:defRPr>
+            </a:pPr>
+          </a:p>
+          <a:p>
+            <a:pPr>
+              <a:defRPr sz="2000">
                 <a:solidFill>
                   <a:srgbClr val="202020"/>
                 </a:solidFill>
@@ -4023,27 +3939,6 @@
             </a:pPr>
             <a:r>
               <a:t>来源：`20260105_frustrated_fm/spin_wave_dynamics/freq_sweep/plane_wave/srcX/{02ns, 05ns}/`</a:t>
-            </a:r>
-          </a:p>
-          <a:p>
-            <a:pPr>
-              <a:defRPr sz="1300">
-                <a:solidFill>
-                  <a:srgbClr val="202020"/>
-                </a:solidFill>
-              </a:defRPr>
-            </a:pPr>
-          </a:p>
-          <a:p>
-            <a:pPr>
-              <a:defRPr sz="1300">
-                <a:solidFill>
-                  <a:srgbClr val="202020"/>
-                </a:solidFill>
-              </a:defRPr>
-            </a:pPr>
-            <a:r>
-              <a:t>---</a:t>
             </a:r>
           </a:p>
         </p:txBody>
@@ -4113,7 +4008,7 @@
           <a:lstStyle/>
           <a:p>
             <a:pPr>
-              <a:defRPr sz="2200" b="1">
+              <a:defRPr sz="2000" b="1">
                 <a:solidFill>
                   <a:srgbClr val="1F2D5A"/>
                 </a:solidFill>
@@ -4148,7 +4043,7 @@
           <a:lstStyle/>
           <a:p>
             <a:pPr>
-              <a:defRPr sz="1300">
+              <a:defRPr sz="2000">
                 <a:solidFill>
                   <a:srgbClr val="202020"/>
                 </a:solidFill>
@@ -4160,28 +4055,28 @@
           </a:p>
           <a:p>
             <a:pPr>
-              <a:defRPr sz="1300">
-                <a:solidFill>
-                  <a:srgbClr val="202020"/>
-                </a:solidFill>
-              </a:defRPr>
-            </a:pPr>
-          </a:p>
-          <a:p>
-            <a:pPr>
-              <a:defRPr sz="1300">
-                <a:solidFill>
-                  <a:srgbClr val="202020"/>
-                </a:solidFill>
-              </a:defRPr>
-            </a:pPr>
-            <a:r>
-              <a:t>**结论**：</a:t>
-            </a:r>
-          </a:p>
-          <a:p>
-            <a:pPr>
-              <a:defRPr sz="1300">
+              <a:defRPr sz="2000">
+                <a:solidFill>
+                  <a:srgbClr val="202020"/>
+                </a:solidFill>
+              </a:defRPr>
+            </a:pPr>
+          </a:p>
+          <a:p>
+            <a:pPr>
+              <a:defRPr sz="2000">
+                <a:solidFill>
+                  <a:srgbClr val="202020"/>
+                </a:solidFill>
+              </a:defRPr>
+            </a:pPr>
+            <a:r>
+              <a:t>结论：</a:t>
+            </a:r>
+          </a:p>
+          <a:p>
+            <a:pPr>
+              <a:defRPr sz="2000">
                 <a:solidFill>
                   <a:srgbClr val="202020"/>
                 </a:solidFill>
@@ -4193,7 +4088,7 @@
           </a:p>
           <a:p>
             <a:pPr>
-              <a:defRPr sz="1300">
+              <a:defRPr sz="2000">
                 <a:solidFill>
                   <a:srgbClr val="202020"/>
                 </a:solidFill>
@@ -4205,7 +4100,7 @@
           </a:p>
           <a:p>
             <a:pPr>
-              <a:defRPr sz="1300">
+              <a:defRPr sz="2000">
                 <a:solidFill>
                   <a:srgbClr val="202020"/>
                 </a:solidFill>
@@ -4217,7 +4112,7 @@
           </a:p>
           <a:p>
             <a:pPr>
-              <a:defRPr sz="1300">
+              <a:defRPr sz="2000">
                 <a:solidFill>
                   <a:srgbClr val="202020"/>
                 </a:solidFill>
@@ -4229,16 +4124,16 @@
           </a:p>
           <a:p>
             <a:pPr>
-              <a:defRPr sz="1300">
-                <a:solidFill>
-                  <a:srgbClr val="202020"/>
-                </a:solidFill>
-              </a:defRPr>
-            </a:pPr>
-          </a:p>
-          <a:p>
-            <a:pPr>
-              <a:defRPr sz="1300">
+              <a:defRPr sz="2000">
+                <a:solidFill>
+                  <a:srgbClr val="202020"/>
+                </a:solidFill>
+              </a:defRPr>
+            </a:pPr>
+          </a:p>
+          <a:p>
+            <a:pPr>
+              <a:defRPr sz="2000">
                 <a:solidFill>
                   <a:srgbClr val="202020"/>
                 </a:solidFill>
@@ -4246,27 +4141,6 @@
             </a:pPr>
             <a:r>
               <a:t>来源：`20260105_frustrated_fm/spin_wave_dynamics/freq_sweep/plane_wave/srcZ/`</a:t>
-            </a:r>
-          </a:p>
-          <a:p>
-            <a:pPr>
-              <a:defRPr sz="1300">
-                <a:solidFill>
-                  <a:srgbClr val="202020"/>
-                </a:solidFill>
-              </a:defRPr>
-            </a:pPr>
-          </a:p>
-          <a:p>
-            <a:pPr>
-              <a:defRPr sz="1300">
-                <a:solidFill>
-                  <a:srgbClr val="202020"/>
-                </a:solidFill>
-              </a:defRPr>
-            </a:pPr>
-            <a:r>
-              <a:t>---</a:t>
             </a:r>
           </a:p>
         </p:txBody>
@@ -4336,7 +4210,7 @@
           <a:lstStyle/>
           <a:p>
             <a:pPr>
-              <a:defRPr sz="2200" b="1">
+              <a:defRPr sz="2000" b="1">
                 <a:solidFill>
                   <a:srgbClr val="1F2D5A"/>
                 </a:solidFill>
@@ -4371,7 +4245,7 @@
           <a:lstStyle/>
           <a:p>
             <a:pPr>
-              <a:defRPr sz="1300">
+              <a:defRPr sz="2000">
                 <a:solidFill>
                   <a:srgbClr val="202020"/>
                 </a:solidFill>
@@ -4383,49 +4257,49 @@
           </a:p>
           <a:p>
             <a:pPr>
-              <a:defRPr sz="1300">
-                <a:solidFill>
-                  <a:srgbClr val="202020"/>
-                </a:solidFill>
-              </a:defRPr>
-            </a:pPr>
-          </a:p>
-          <a:p>
-            <a:pPr>
-              <a:defRPr sz="1300">
-                <a:solidFill>
-                  <a:srgbClr val="202020"/>
-                </a:solidFill>
-              </a:defRPr>
-            </a:pPr>
-            <a:r>
-              <a:t>**毕设原结论**：v∝B¹·⁹⁹ 幂律（仅基于 B=0.5/1.0/2.0 T 三点拟合）。</a:t>
-            </a:r>
-          </a:p>
-          <a:p>
-            <a:pPr>
-              <a:defRPr sz="1300">
-                <a:solidFill>
-                  <a:srgbClr val="202020"/>
-                </a:solidFill>
-              </a:defRPr>
-            </a:pPr>
-          </a:p>
-          <a:p>
-            <a:pPr>
-              <a:defRPr sz="1300">
-                <a:solidFill>
-                  <a:srgbClr val="202020"/>
-                </a:solidFill>
-              </a:defRPr>
-            </a:pPr>
-            <a:r>
-              <a:t>**已推翻**：</a:t>
-            </a:r>
-          </a:p>
-          <a:p>
-            <a:pPr>
-              <a:defRPr sz="1300">
+              <a:defRPr sz="2000">
+                <a:solidFill>
+                  <a:srgbClr val="202020"/>
+                </a:solidFill>
+              </a:defRPr>
+            </a:pPr>
+          </a:p>
+          <a:p>
+            <a:pPr>
+              <a:defRPr sz="2000">
+                <a:solidFill>
+                  <a:srgbClr val="202020"/>
+                </a:solidFill>
+              </a:defRPr>
+            </a:pPr>
+            <a:r>
+              <a:t>毕设原结论：v∝B¹·⁹⁹ 幂律（仅基于 B=0.5/1.0/2.0 T 三点拟合）。</a:t>
+            </a:r>
+          </a:p>
+          <a:p>
+            <a:pPr>
+              <a:defRPr sz="2000">
+                <a:solidFill>
+                  <a:srgbClr val="202020"/>
+                </a:solidFill>
+              </a:defRPr>
+            </a:pPr>
+          </a:p>
+          <a:p>
+            <a:pPr>
+              <a:defRPr sz="2000">
+                <a:solidFill>
+                  <a:srgbClr val="202020"/>
+                </a:solidFill>
+              </a:defRPr>
+            </a:pPr>
+            <a:r>
+              <a:t>已推翻：</a:t>
+            </a:r>
+          </a:p>
+          <a:p>
+            <a:pPr>
+              <a:defRPr sz="2000">
                 <a:solidFill>
                   <a:srgbClr val="202020"/>
                 </a:solidFill>
@@ -4437,7 +4311,7 @@
           </a:p>
           <a:p>
             <a:pPr>
-              <a:defRPr sz="1300">
+              <a:defRPr sz="2000">
                 <a:solidFill>
                   <a:srgbClr val="202020"/>
                 </a:solidFill>
@@ -4449,7 +4323,7 @@
           </a:p>
           <a:p>
             <a:pPr>
-              <a:defRPr sz="1300">
+              <a:defRPr sz="2000">
                 <a:solidFill>
                   <a:srgbClr val="202020"/>
                 </a:solidFill>
@@ -4461,7 +4335,7 @@
           </a:p>
           <a:p>
             <a:pPr>
-              <a:defRPr sz="1300">
+              <a:defRPr sz="2000">
                 <a:solidFill>
                   <a:srgbClr val="202020"/>
                 </a:solidFill>
@@ -4473,7 +4347,7 @@
           </a:p>
           <a:p>
             <a:pPr>
-              <a:defRPr sz="1300">
+              <a:defRPr sz="2000">
                 <a:solidFill>
                   <a:srgbClr val="202020"/>
                 </a:solidFill>
@@ -4485,37 +4359,37 @@
           </a:p>
           <a:p>
             <a:pPr>
-              <a:defRPr sz="1300">
-                <a:solidFill>
-                  <a:srgbClr val="202020"/>
-                </a:solidFill>
-              </a:defRPr>
-            </a:pPr>
-          </a:p>
-          <a:p>
-            <a:pPr>
-              <a:defRPr sz="1300">
-                <a:solidFill>
-                  <a:srgbClr val="202020"/>
-                </a:solidFill>
-              </a:defRPr>
-            </a:pPr>
-            <a:r>
-              <a:t>**现状**：方向反转 + 幂律两个现象并存，但准确标度律和精确 Bc 都未确定。</a:t>
-            </a:r>
-          </a:p>
-          <a:p>
-            <a:pPr>
-              <a:defRPr sz="1300">
-                <a:solidFill>
-                  <a:srgbClr val="202020"/>
-                </a:solidFill>
-              </a:defRPr>
-            </a:pPr>
-          </a:p>
-          <a:p>
-            <a:pPr>
-              <a:defRPr sz="1300">
+              <a:defRPr sz="2000">
+                <a:solidFill>
+                  <a:srgbClr val="202020"/>
+                </a:solidFill>
+              </a:defRPr>
+            </a:pPr>
+          </a:p>
+          <a:p>
+            <a:pPr>
+              <a:defRPr sz="2000">
+                <a:solidFill>
+                  <a:srgbClr val="202020"/>
+                </a:solidFill>
+              </a:defRPr>
+            </a:pPr>
+            <a:r>
+              <a:t>现状：方向反转 + 幂律两个现象并存，但准确标度律和精确 Bc 都未确定。</a:t>
+            </a:r>
+          </a:p>
+          <a:p>
+            <a:pPr>
+              <a:defRPr sz="2000">
+                <a:solidFill>
+                  <a:srgbClr val="202020"/>
+                </a:solidFill>
+              </a:defRPr>
+            </a:pPr>
+          </a:p>
+          <a:p>
+            <a:pPr>
+              <a:defRPr sz="2000">
                 <a:solidFill>
                   <a:srgbClr val="202020"/>
                 </a:solidFill>
@@ -4523,27 +4397,6 @@
             </a:pPr>
             <a:r>
               <a:t>来源：`20260105_frustrated_fm/spin_wave_dynamics/amplitude_sweep/plane_wave/`</a:t>
-            </a:r>
-          </a:p>
-          <a:p>
-            <a:pPr>
-              <a:defRPr sz="1300">
-                <a:solidFill>
-                  <a:srgbClr val="202020"/>
-                </a:solidFill>
-              </a:defRPr>
-            </a:pPr>
-          </a:p>
-          <a:p>
-            <a:pPr>
-              <a:defRPr sz="1300">
-                <a:solidFill>
-                  <a:srgbClr val="202020"/>
-                </a:solidFill>
-              </a:defRPr>
-            </a:pPr>
-            <a:r>
-              <a:t>---</a:t>
             </a:r>
           </a:p>
         </p:txBody>
@@ -4613,7 +4466,7 @@
           <a:lstStyle/>
           <a:p>
             <a:pPr>
-              <a:defRPr sz="2200" b="1">
+              <a:defRPr sz="2000" b="1">
                 <a:solidFill>
                   <a:srgbClr val="1F2D5A"/>
                 </a:solidFill>
@@ -4648,7 +4501,7 @@
           <a:lstStyle/>
           <a:p>
             <a:pPr>
-              <a:defRPr sz="1300">
+              <a:defRPr sz="2000">
                 <a:solidFill>
                   <a:srgbClr val="202020"/>
                 </a:solidFill>
@@ -4660,16 +4513,16 @@
           </a:p>
           <a:p>
             <a:pPr>
-              <a:defRPr sz="1300">
-                <a:solidFill>
-                  <a:srgbClr val="202020"/>
-                </a:solidFill>
-              </a:defRPr>
-            </a:pPr>
-          </a:p>
-          <a:p>
-            <a:pPr>
-              <a:defRPr sz="1300">
+              <a:defRPr sz="2000">
+                <a:solidFill>
+                  <a:srgbClr val="202020"/>
+                </a:solidFill>
+              </a:defRPr>
+            </a:pPr>
+          </a:p>
+          <a:p>
+            <a:pPr>
+              <a:defRPr sz="2000">
                 <a:solidFill>
                   <a:srgbClr val="202020"/>
                 </a:solidFill>
@@ -4681,16 +4534,16 @@
           </a:p>
           <a:p>
             <a:pPr>
-              <a:defRPr sz="1300">
-                <a:solidFill>
-                  <a:srgbClr val="202020"/>
-                </a:solidFill>
-              </a:defRPr>
-            </a:pPr>
-          </a:p>
-          <a:p>
-            <a:pPr>
-              <a:defRPr sz="1300">
+              <a:defRPr sz="2000">
+                <a:solidFill>
+                  <a:srgbClr val="202020"/>
+                </a:solidFill>
+              </a:defRPr>
+            </a:pPr>
+          </a:p>
+          <a:p>
+            <a:pPr>
+              <a:defRPr sz="2000">
                 <a:solidFill>
                   <a:srgbClr val="202020"/>
                 </a:solidFill>
@@ -4698,27 +4551,6 @@
             </a:pPr>
             <a:r>
               <a:t>无图。来源：`20260105_frustrated_fm/spin_wave_dynamics/amplitude_sweep/plane_wave_srcZ/`</a:t>
-            </a:r>
-          </a:p>
-          <a:p>
-            <a:pPr>
-              <a:defRPr sz="1300">
-                <a:solidFill>
-                  <a:srgbClr val="202020"/>
-                </a:solidFill>
-              </a:defRPr>
-            </a:pPr>
-          </a:p>
-          <a:p>
-            <a:pPr>
-              <a:defRPr sz="1300">
-                <a:solidFill>
-                  <a:srgbClr val="202020"/>
-                </a:solidFill>
-              </a:defRPr>
-            </a:pPr>
-            <a:r>
-              <a:t>---</a:t>
             </a:r>
           </a:p>
         </p:txBody>
@@ -4764,7 +4596,7 @@
           <a:lstStyle/>
           <a:p>
             <a:pPr>
-              <a:defRPr sz="2200" b="1">
+              <a:defRPr sz="2000" b="1">
                 <a:solidFill>
                   <a:srgbClr val="1F2D5A"/>
                 </a:solidFill>
@@ -4799,7 +4631,7 @@
           <a:lstStyle/>
           <a:p>
             <a:pPr>
-              <a:defRPr sz="1300">
+              <a:defRPr sz="2000">
                 <a:solidFill>
                   <a:srgbClr val="202020"/>
                 </a:solidFill>
@@ -4811,7 +4643,7 @@
           </a:p>
           <a:p>
             <a:pPr>
-              <a:defRPr sz="1300">
+              <a:defRPr sz="2000">
                 <a:solidFill>
                   <a:srgbClr val="202020"/>
                 </a:solidFill>
@@ -4823,7 +4655,7 @@
           </a:p>
           <a:p>
             <a:pPr>
-              <a:defRPr sz="1300">
+              <a:defRPr sz="2000">
                 <a:solidFill>
                   <a:srgbClr val="202020"/>
                 </a:solidFill>
@@ -4835,16 +4667,16 @@
           </a:p>
           <a:p>
             <a:pPr>
-              <a:defRPr sz="1300">
-                <a:solidFill>
-                  <a:srgbClr val="202020"/>
-                </a:solidFill>
-              </a:defRPr>
-            </a:pPr>
-          </a:p>
-          <a:p>
-            <a:pPr>
-              <a:defRPr sz="1300">
+              <a:defRPr sz="2000">
+                <a:solidFill>
+                  <a:srgbClr val="202020"/>
+                </a:solidFill>
+              </a:defRPr>
+            </a:pPr>
+          </a:p>
+          <a:p>
+            <a:pPr>
+              <a:defRPr sz="2000">
                 <a:solidFill>
                   <a:srgbClr val="202020"/>
                 </a:solidFill>
@@ -4856,16 +4688,16 @@
           </a:p>
           <a:p>
             <a:pPr>
-              <a:defRPr sz="1300">
-                <a:solidFill>
-                  <a:srgbClr val="202020"/>
-                </a:solidFill>
-              </a:defRPr>
-            </a:pPr>
-          </a:p>
-          <a:p>
-            <a:pPr>
-              <a:defRPr sz="1300">
+              <a:defRPr sz="2000">
+                <a:solidFill>
+                  <a:srgbClr val="202020"/>
+                </a:solidFill>
+              </a:defRPr>
+            </a:pPr>
+          </a:p>
+          <a:p>
+            <a:pPr>
+              <a:defRPr sz="2000">
                 <a:solidFill>
                   <a:srgbClr val="202020"/>
                 </a:solidFill>
@@ -4873,27 +4705,6 @@
             </a:pPr>
             <a:r>
               <a:t>无图。</a:t>
-            </a:r>
-          </a:p>
-          <a:p>
-            <a:pPr>
-              <a:defRPr sz="1300">
-                <a:solidFill>
-                  <a:srgbClr val="202020"/>
-                </a:solidFill>
-              </a:defRPr>
-            </a:pPr>
-          </a:p>
-          <a:p>
-            <a:pPr>
-              <a:defRPr sz="1300">
-                <a:solidFill>
-                  <a:srgbClr val="202020"/>
-                </a:solidFill>
-              </a:defRPr>
-            </a:pPr>
-            <a:r>
-              <a:t>---</a:t>
             </a:r>
           </a:p>
         </p:txBody>
@@ -4939,7 +4750,7 @@
           <a:lstStyle/>
           <a:p>
             <a:pPr>
-              <a:defRPr sz="2200" b="1">
+              <a:defRPr sz="2000" b="1">
                 <a:solidFill>
                   <a:srgbClr val="1F2D5A"/>
                 </a:solidFill>
@@ -4974,7 +4785,7 @@
           <a:lstStyle/>
           <a:p>
             <a:pPr>
-              <a:defRPr sz="1300">
+              <a:defRPr sz="2000">
                 <a:solidFill>
                   <a:srgbClr val="202020"/>
                 </a:solidFill>
@@ -4986,28 +4797,28 @@
           </a:p>
           <a:p>
             <a:pPr>
-              <a:defRPr sz="1300">
-                <a:solidFill>
-                  <a:srgbClr val="202020"/>
-                </a:solidFill>
-              </a:defRPr>
-            </a:pPr>
-          </a:p>
-          <a:p>
-            <a:pPr>
-              <a:defRPr sz="1300">
-                <a:solidFill>
-                  <a:srgbClr val="202020"/>
-                </a:solidFill>
-              </a:defRPr>
-            </a:pPr>
-            <a:r>
-              <a:t>**结论**（B 设备数据迁回 2026-04-09）：</a:t>
-            </a:r>
-          </a:p>
-          <a:p>
-            <a:pPr>
-              <a:defRPr sz="1300">
+              <a:defRPr sz="2000">
+                <a:solidFill>
+                  <a:srgbClr val="202020"/>
+                </a:solidFill>
+              </a:defRPr>
+            </a:pPr>
+          </a:p>
+          <a:p>
+            <a:pPr>
+              <a:defRPr sz="2000">
+                <a:solidFill>
+                  <a:srgbClr val="202020"/>
+                </a:solidFill>
+              </a:defRPr>
+            </a:pPr>
+            <a:r>
+              <a:t>结论（B 设备数据迁回 2026-04-09）：</a:t>
+            </a:r>
+          </a:p>
+          <a:p>
+            <a:pPr>
+              <a:defRPr sz="2000">
                 <a:solidFill>
                   <a:srgbClr val="202020"/>
                 </a:solidFill>
@@ -5019,31 +4830,31 @@
           </a:p>
           <a:p>
             <a:pPr>
-              <a:defRPr sz="1300">
-                <a:solidFill>
-                  <a:srgbClr val="202020"/>
-                </a:solidFill>
-              </a:defRPr>
-            </a:pPr>
-            <a:r>
-              <a:t>- **全频段 +z**，与平面源 srcX 一致</a:t>
-            </a:r>
-          </a:p>
-          <a:p>
-            <a:pPr>
-              <a:defRPr sz="1300">
-                <a:solidFill>
-                  <a:srgbClr val="202020"/>
-                </a:solidFill>
-              </a:defRPr>
-            </a:pPr>
-            <a:r>
-              <a:t>- **死区消失**（平面源有 400-600 GHz 死区）</a:t>
-            </a:r>
-          </a:p>
-          <a:p>
-            <a:pPr>
-              <a:defRPr sz="1300">
+              <a:defRPr sz="2000">
+                <a:solidFill>
+                  <a:srgbClr val="202020"/>
+                </a:solidFill>
+              </a:defRPr>
+            </a:pPr>
+            <a:r>
+              <a:t>- 全频段 +z，与平面源 srcX 一致</a:t>
+            </a:r>
+          </a:p>
+          <a:p>
+            <a:pPr>
+              <a:defRPr sz="2000">
+                <a:solidFill>
+                  <a:srgbClr val="202020"/>
+                </a:solidFill>
+              </a:defRPr>
+            </a:pPr>
+            <a:r>
+              <a:t>- 死区消失（平面源有 400-600 GHz 死区）</a:t>
+            </a:r>
+          </a:p>
+          <a:p>
+            <a:pPr>
+              <a:defRPr sz="2000">
                 <a:solidFill>
                   <a:srgbClr val="202020"/>
                 </a:solidFill>
@@ -5055,16 +4866,16 @@
           </a:p>
           <a:p>
             <a:pPr>
-              <a:defRPr sz="1300">
-                <a:solidFill>
-                  <a:srgbClr val="202020"/>
-                </a:solidFill>
-              </a:defRPr>
-            </a:pPr>
-          </a:p>
-          <a:p>
-            <a:pPr>
-              <a:defRPr sz="1300">
+              <a:defRPr sz="2000">
+                <a:solidFill>
+                  <a:srgbClr val="202020"/>
+                </a:solidFill>
+              </a:defRPr>
+            </a:pPr>
+          </a:p>
+          <a:p>
+            <a:pPr>
+              <a:defRPr sz="2000">
                 <a:solidFill>
                   <a:srgbClr val="202020"/>
                 </a:solidFill>
@@ -5072,27 +4883,6 @@
             </a:pPr>
             <a:r>
               <a:t>来源：`20260105_frustrated_fm/spin_wave_dynamics/freq_sweep/point_source/srcX/`</a:t>
-            </a:r>
-          </a:p>
-          <a:p>
-            <a:pPr>
-              <a:defRPr sz="1300">
-                <a:solidFill>
-                  <a:srgbClr val="202020"/>
-                </a:solidFill>
-              </a:defRPr>
-            </a:pPr>
-          </a:p>
-          <a:p>
-            <a:pPr>
-              <a:defRPr sz="1300">
-                <a:solidFill>
-                  <a:srgbClr val="202020"/>
-                </a:solidFill>
-              </a:defRPr>
-            </a:pPr>
-            <a:r>
-              <a:t>---</a:t>
             </a:r>
           </a:p>
         </p:txBody>
@@ -5162,7 +4952,7 @@
           <a:lstStyle/>
           <a:p>
             <a:pPr>
-              <a:defRPr sz="2200" b="1">
+              <a:defRPr sz="2000" b="1">
                 <a:solidFill>
                   <a:srgbClr val="1F2D5A"/>
                 </a:solidFill>
@@ -5197,7 +4987,7 @@
           <a:lstStyle/>
           <a:p>
             <a:pPr>
-              <a:defRPr sz="1300">
+              <a:defRPr sz="2000">
                 <a:solidFill>
                   <a:srgbClr val="202020"/>
                 </a:solidFill>
@@ -5209,28 +4999,28 @@
           </a:p>
           <a:p>
             <a:pPr>
-              <a:defRPr sz="1300">
-                <a:solidFill>
-                  <a:srgbClr val="202020"/>
-                </a:solidFill>
-              </a:defRPr>
-            </a:pPr>
-          </a:p>
-          <a:p>
-            <a:pPr>
-              <a:defRPr sz="1300">
-                <a:solidFill>
-                  <a:srgbClr val="202020"/>
-                </a:solidFill>
-              </a:defRPr>
-            </a:pPr>
-            <a:r>
-              <a:t>**结论**：</a:t>
-            </a:r>
-          </a:p>
-          <a:p>
-            <a:pPr>
-              <a:defRPr sz="1300">
+              <a:defRPr sz="2000">
+                <a:solidFill>
+                  <a:srgbClr val="202020"/>
+                </a:solidFill>
+              </a:defRPr>
+            </a:pPr>
+          </a:p>
+          <a:p>
+            <a:pPr>
+              <a:defRPr sz="2000">
+                <a:solidFill>
+                  <a:srgbClr val="202020"/>
+                </a:solidFill>
+              </a:defRPr>
+            </a:pPr>
+            <a:r>
+              <a:t>结论：</a:t>
+            </a:r>
+          </a:p>
+          <a:p>
+            <a:pPr>
+              <a:defRPr sz="2000">
                 <a:solidFill>
                   <a:srgbClr val="202020"/>
                 </a:solidFill>
@@ -5242,19 +5032,19 @@
           </a:p>
           <a:p>
             <a:pPr>
-              <a:defRPr sz="1300">
-                <a:solidFill>
-                  <a:srgbClr val="202020"/>
-                </a:solidFill>
-              </a:defRPr>
-            </a:pPr>
-            <a:r>
-              <a:t>- **方向分布更复杂**：100/200/300/400 / 600 / 900 GHz +z，500 / 700 / 800 GHz -z（vs 平面源仅 100 GHz 异常）</a:t>
-            </a:r>
-          </a:p>
-          <a:p>
-            <a:pPr>
-              <a:defRPr sz="1300">
+              <a:defRPr sz="2000">
+                <a:solidFill>
+                  <a:srgbClr val="202020"/>
+                </a:solidFill>
+              </a:defRPr>
+            </a:pPr>
+            <a:r>
+              <a:t>- 方向分布更复杂：100/200/300/400 / 600 / 900 GHz +z，500 / 700 / 800 GHz -z（vs 平面源仅 100 GHz 异常）</a:t>
+            </a:r>
+          </a:p>
+          <a:p>
+            <a:pPr>
+              <a:defRPr sz="2000">
                 <a:solidFill>
                   <a:srgbClr val="202020"/>
                 </a:solidFill>
@@ -5266,16 +5056,16 @@
           </a:p>
           <a:p>
             <a:pPr>
-              <a:defRPr sz="1300">
-                <a:solidFill>
-                  <a:srgbClr val="202020"/>
-                </a:solidFill>
-              </a:defRPr>
-            </a:pPr>
-          </a:p>
-          <a:p>
-            <a:pPr>
-              <a:defRPr sz="1300">
+              <a:defRPr sz="2000">
+                <a:solidFill>
+                  <a:srgbClr val="202020"/>
+                </a:solidFill>
+              </a:defRPr>
+            </a:pPr>
+          </a:p>
+          <a:p>
+            <a:pPr>
+              <a:defRPr sz="2000">
                 <a:solidFill>
                   <a:srgbClr val="202020"/>
                 </a:solidFill>
@@ -5287,16 +5077,16 @@
           </a:p>
           <a:p>
             <a:pPr>
-              <a:defRPr sz="1300">
-                <a:solidFill>
-                  <a:srgbClr val="202020"/>
-                </a:solidFill>
-              </a:defRPr>
-            </a:pPr>
-          </a:p>
-          <a:p>
-            <a:pPr>
-              <a:defRPr sz="1300">
+              <a:defRPr sz="2000">
+                <a:solidFill>
+                  <a:srgbClr val="202020"/>
+                </a:solidFill>
+              </a:defRPr>
+            </a:pPr>
+          </a:p>
+          <a:p>
+            <a:pPr>
+              <a:defRPr sz="2000">
                 <a:solidFill>
                   <a:srgbClr val="202020"/>
                 </a:solidFill>
@@ -5304,27 +5094,6 @@
             </a:pPr>
             <a:r>
               <a:t>无图（共用 P18 图）。来源：`20260105_frustrated_fm/spin_wave_dynamics/freq_sweep/point_source/srcZ/`</a:t>
-            </a:r>
-          </a:p>
-          <a:p>
-            <a:pPr>
-              <a:defRPr sz="1300">
-                <a:solidFill>
-                  <a:srgbClr val="202020"/>
-                </a:solidFill>
-              </a:defRPr>
-            </a:pPr>
-          </a:p>
-          <a:p>
-            <a:pPr>
-              <a:defRPr sz="1300">
-                <a:solidFill>
-                  <a:srgbClr val="202020"/>
-                </a:solidFill>
-              </a:defRPr>
-            </a:pPr>
-            <a:r>
-              <a:t>---</a:t>
             </a:r>
           </a:p>
         </p:txBody>
@@ -5370,7 +5139,7 @@
           <a:lstStyle/>
           <a:p>
             <a:pPr>
-              <a:defRPr sz="2200" b="1">
+              <a:defRPr sz="2000" b="1">
                 <a:solidFill>
                   <a:srgbClr val="1F2D5A"/>
                 </a:solidFill>
@@ -5405,7 +5174,7 @@
           <a:lstStyle/>
           <a:p>
             <a:pPr>
-              <a:defRPr sz="1300">
+              <a:defRPr sz="2000">
                 <a:solidFill>
                   <a:srgbClr val="202020"/>
                 </a:solidFill>
@@ -5417,16 +5186,16 @@
           </a:p>
           <a:p>
             <a:pPr>
-              <a:defRPr sz="1300">
-                <a:solidFill>
-                  <a:srgbClr val="202020"/>
-                </a:solidFill>
-              </a:defRPr>
-            </a:pPr>
-          </a:p>
-          <a:p>
-            <a:pPr>
-              <a:defRPr sz="1300">
+              <a:defRPr sz="2000">
+                <a:solidFill>
+                  <a:srgbClr val="202020"/>
+                </a:solidFill>
+              </a:defRPr>
+            </a:pPr>
+          </a:p>
+          <a:p>
+            <a:pPr>
+              <a:defRPr sz="2000">
                 <a:solidFill>
                   <a:srgbClr val="202020"/>
                 </a:solidFill>
@@ -5438,16 +5207,16 @@
           </a:p>
           <a:p>
             <a:pPr>
-              <a:defRPr sz="1300">
-                <a:solidFill>
-                  <a:srgbClr val="202020"/>
-                </a:solidFill>
-              </a:defRPr>
-            </a:pPr>
-          </a:p>
-          <a:p>
-            <a:pPr>
-              <a:defRPr sz="1300">
+              <a:defRPr sz="2000">
+                <a:solidFill>
+                  <a:srgbClr val="202020"/>
+                </a:solidFill>
+              </a:defRPr>
+            </a:pPr>
+          </a:p>
+          <a:p>
+            <a:pPr>
+              <a:defRPr sz="2000">
                 <a:solidFill>
                   <a:srgbClr val="202020"/>
                 </a:solidFill>
@@ -5455,27 +5224,6 @@
             </a:pPr>
             <a:r>
               <a:t>无图。来源：`20251219_dmi_fm/failed_attempts/bulk_pbc_tests/`（4 runs）</a:t>
-            </a:r>
-          </a:p>
-          <a:p>
-            <a:pPr>
-              <a:defRPr sz="1300">
-                <a:solidFill>
-                  <a:srgbClr val="202020"/>
-                </a:solidFill>
-              </a:defRPr>
-            </a:pPr>
-          </a:p>
-          <a:p>
-            <a:pPr>
-              <a:defRPr sz="1300">
-                <a:solidFill>
-                  <a:srgbClr val="202020"/>
-                </a:solidFill>
-              </a:defRPr>
-            </a:pPr>
-            <a:r>
-              <a:t>---</a:t>
             </a:r>
           </a:p>
         </p:txBody>
@@ -5521,7 +5269,7 @@
           <a:lstStyle/>
           <a:p>
             <a:pPr>
-              <a:defRPr sz="2200" b="1">
+              <a:defRPr sz="2000" b="1">
                 <a:solidFill>
                   <a:srgbClr val="1F2D5A"/>
                 </a:solidFill>
@@ -5556,7 +5304,7 @@
           <a:lstStyle/>
           <a:p>
             <a:pPr>
-              <a:defRPr sz="1300">
+              <a:defRPr sz="2000">
                 <a:solidFill>
                   <a:srgbClr val="202020"/>
                 </a:solidFill>
@@ -5568,16 +5316,16 @@
           </a:p>
           <a:p>
             <a:pPr>
-              <a:defRPr sz="1300">
-                <a:solidFill>
-                  <a:srgbClr val="202020"/>
-                </a:solidFill>
-              </a:defRPr>
-            </a:pPr>
-          </a:p>
-          <a:p>
-            <a:pPr>
-              <a:defRPr sz="1300">
+              <a:defRPr sz="2000">
+                <a:solidFill>
+                  <a:srgbClr val="202020"/>
+                </a:solidFill>
+              </a:defRPr>
+            </a:pPr>
+          </a:p>
+          <a:p>
+            <a:pPr>
+              <a:defRPr sz="2000">
                 <a:solidFill>
                   <a:srgbClr val="202020"/>
                 </a:solidFill>
@@ -5589,7 +5337,7 @@
           </a:p>
           <a:p>
             <a:pPr>
-              <a:defRPr sz="1300">
+              <a:defRPr sz="2000">
                 <a:solidFill>
                   <a:srgbClr val="202020"/>
                 </a:solidFill>
@@ -5601,7 +5349,7 @@
           </a:p>
           <a:p>
             <a:pPr>
-              <a:defRPr sz="1300">
+              <a:defRPr sz="2000">
                 <a:solidFill>
                   <a:srgbClr val="202020"/>
                 </a:solidFill>
@@ -5613,19 +5361,19 @@
           </a:p>
           <a:p>
             <a:pPr>
-              <a:defRPr sz="1300">
-                <a:solidFill>
-                  <a:srgbClr val="202020"/>
-                </a:solidFill>
-              </a:defRPr>
-            </a:pPr>
-            <a:r>
-              <a:t>| B500 | **停在 0.433 ns**，未续跑成功 |</a:t>
-            </a:r>
-          </a:p>
-          <a:p>
-            <a:pPr>
-              <a:defRPr sz="1300">
+              <a:defRPr sz="2000">
+                <a:solidFill>
+                  <a:srgbClr val="202020"/>
+                </a:solidFill>
+              </a:defRPr>
+            </a:pPr>
+            <a:r>
+              <a:t>| B500 | 停在 0.433 ns，未续跑成功 |</a:t>
+            </a:r>
+          </a:p>
+          <a:p>
+            <a:pPr>
+              <a:defRPr sz="2000">
                 <a:solidFill>
                   <a:srgbClr val="202020"/>
                 </a:solidFill>
@@ -5637,16 +5385,16 @@
           </a:p>
           <a:p>
             <a:pPr>
-              <a:defRPr sz="1300">
-                <a:solidFill>
-                  <a:srgbClr val="202020"/>
-                </a:solidFill>
-              </a:defRPr>
-            </a:pPr>
-          </a:p>
-          <a:p>
-            <a:pPr>
-              <a:defRPr sz="1300">
+              <a:defRPr sz="2000">
+                <a:solidFill>
+                  <a:srgbClr val="202020"/>
+                </a:solidFill>
+              </a:defRPr>
+            </a:pPr>
+          </a:p>
+          <a:p>
+            <a:pPr>
+              <a:defRPr sz="2000">
                 <a:solidFill>
                   <a:srgbClr val="202020"/>
                 </a:solidFill>
@@ -5658,16 +5406,16 @@
           </a:p>
           <a:p>
             <a:pPr>
-              <a:defRPr sz="1300">
-                <a:solidFill>
-                  <a:srgbClr val="202020"/>
-                </a:solidFill>
-              </a:defRPr>
-            </a:pPr>
-          </a:p>
-          <a:p>
-            <a:pPr>
-              <a:defRPr sz="1300">
+              <a:defRPr sz="2000">
+                <a:solidFill>
+                  <a:srgbClr val="202020"/>
+                </a:solidFill>
+              </a:defRPr>
+            </a:pPr>
+          </a:p>
+          <a:p>
+            <a:pPr>
+              <a:defRPr sz="2000">
                 <a:solidFill>
                   <a:srgbClr val="202020"/>
                 </a:solidFill>
@@ -5675,27 +5423,6 @@
             </a:pPr>
             <a:r>
               <a:t>无图。来源：`20260105_frustrated_fm/spin_wave_dynamics/amplitude_sweep/point_source/`</a:t>
-            </a:r>
-          </a:p>
-          <a:p>
-            <a:pPr>
-              <a:defRPr sz="1300">
-                <a:solidFill>
-                  <a:srgbClr val="202020"/>
-                </a:solidFill>
-              </a:defRPr>
-            </a:pPr>
-          </a:p>
-          <a:p>
-            <a:pPr>
-              <a:defRPr sz="1300">
-                <a:solidFill>
-                  <a:srgbClr val="202020"/>
-                </a:solidFill>
-              </a:defRPr>
-            </a:pPr>
-            <a:r>
-              <a:t>---</a:t>
             </a:r>
           </a:p>
         </p:txBody>
@@ -5741,7 +5468,7 @@
           <a:lstStyle/>
           <a:p>
             <a:pPr>
-              <a:defRPr sz="2200" b="1">
+              <a:defRPr sz="2000" b="1">
                 <a:solidFill>
                   <a:srgbClr val="1F2D5A"/>
                 </a:solidFill>
@@ -5776,7 +5503,7 @@
           <a:lstStyle/>
           <a:p>
             <a:pPr>
-              <a:defRPr sz="1300">
+              <a:defRPr sz="2000">
                 <a:solidFill>
                   <a:srgbClr val="202020"/>
                 </a:solidFill>
@@ -5788,16 +5515,16 @@
           </a:p>
           <a:p>
             <a:pPr>
-              <a:defRPr sz="1300">
-                <a:solidFill>
-                  <a:srgbClr val="202020"/>
-                </a:solidFill>
-              </a:defRPr>
-            </a:pPr>
-          </a:p>
-          <a:p>
-            <a:pPr>
-              <a:defRPr sz="1300">
+              <a:defRPr sz="2000">
+                <a:solidFill>
+                  <a:srgbClr val="202020"/>
+                </a:solidFill>
+              </a:defRPr>
+            </a:pPr>
+          </a:p>
+          <a:p>
+            <a:pPr>
+              <a:defRPr sz="2000">
                 <a:solidFill>
                   <a:srgbClr val="202020"/>
                 </a:solidFill>
@@ -5809,16 +5536,16 @@
           </a:p>
           <a:p>
             <a:pPr>
-              <a:defRPr sz="1300">
-                <a:solidFill>
-                  <a:srgbClr val="202020"/>
-                </a:solidFill>
-              </a:defRPr>
-            </a:pPr>
-          </a:p>
-          <a:p>
-            <a:pPr>
-              <a:defRPr sz="1300">
+              <a:defRPr sz="2000">
+                <a:solidFill>
+                  <a:srgbClr val="202020"/>
+                </a:solidFill>
+              </a:defRPr>
+            </a:pPr>
+          </a:p>
+          <a:p>
+            <a:pPr>
+              <a:defRPr sz="2000">
                 <a:solidFill>
                   <a:srgbClr val="202020"/>
                 </a:solidFill>
@@ -5830,16 +5557,16 @@
           </a:p>
           <a:p>
             <a:pPr>
-              <a:defRPr sz="1300">
-                <a:solidFill>
-                  <a:srgbClr val="202020"/>
-                </a:solidFill>
-              </a:defRPr>
-            </a:pPr>
-          </a:p>
-          <a:p>
-            <a:pPr>
-              <a:defRPr sz="1300">
+              <a:defRPr sz="2000">
+                <a:solidFill>
+                  <a:srgbClr val="202020"/>
+                </a:solidFill>
+              </a:defRPr>
+            </a:pPr>
+          </a:p>
+          <a:p>
+            <a:pPr>
+              <a:defRPr sz="2000">
                 <a:solidFill>
                   <a:srgbClr val="202020"/>
                 </a:solidFill>
@@ -5847,27 +5574,6 @@
             </a:pPr>
             <a:r>
               <a:t>无图。来源：`20260105_frustrated_fm/spin_wave_dynamics/multisource_control/{baseline, bidirectional_z/v1}/`</a:t>
-            </a:r>
-          </a:p>
-          <a:p>
-            <a:pPr>
-              <a:defRPr sz="1300">
-                <a:solidFill>
-                  <a:srgbClr val="202020"/>
-                </a:solidFill>
-              </a:defRPr>
-            </a:pPr>
-          </a:p>
-          <a:p>
-            <a:pPr>
-              <a:defRPr sz="1300">
-                <a:solidFill>
-                  <a:srgbClr val="202020"/>
-                </a:solidFill>
-              </a:defRPr>
-            </a:pPr>
-            <a:r>
-              <a:t>---</a:t>
             </a:r>
           </a:p>
         </p:txBody>
@@ -5913,7 +5619,7 @@
           <a:lstStyle/>
           <a:p>
             <a:pPr>
-              <a:defRPr sz="2200" b="1">
+              <a:defRPr sz="2000" b="1">
                 <a:solidFill>
                   <a:srgbClr val="1F2D5A"/>
                 </a:solidFill>
@@ -5948,7 +5654,7 @@
           <a:lstStyle/>
           <a:p>
             <a:pPr>
-              <a:defRPr sz="1300">
+              <a:defRPr sz="2000">
                 <a:solidFill>
                   <a:srgbClr val="202020"/>
                 </a:solidFill>
@@ -5960,19 +5666,19 @@
           </a:p>
           <a:p>
             <a:pPr>
-              <a:defRPr sz="1300">
-                <a:solidFill>
-                  <a:srgbClr val="202020"/>
-                </a:solidFill>
-              </a:defRPr>
-            </a:pPr>
-            <a:r>
-              <a:t>- Phase1 100 GHz：Hopfion 仅 +0.04 nm（**Phase1 太短**）</a:t>
-            </a:r>
-          </a:p>
-          <a:p>
-            <a:pPr>
-              <a:defRPr sz="1300">
+              <a:defRPr sz="2000">
+                <a:solidFill>
+                  <a:srgbClr val="202020"/>
+                </a:solidFill>
+              </a:defRPr>
+            </a:pPr>
+            <a:r>
+              <a:t>- Phase1 100 GHz：Hopfion 仅 +0.04 nm（Phase1 太短）</a:t>
+            </a:r>
+          </a:p>
+          <a:p>
+            <a:pPr>
+              <a:defRPr sz="2000">
                 <a:solidFill>
                   <a:srgbClr val="202020"/>
                 </a:solidFill>
@@ -5984,28 +5690,28 @@
           </a:p>
           <a:p>
             <a:pPr>
-              <a:defRPr sz="1300">
-                <a:solidFill>
-                  <a:srgbClr val="202020"/>
-                </a:solidFill>
-              </a:defRPr>
-            </a:pPr>
-            <a:r>
-              <a:t>- **双向 FAILED**：未观察到 +z → -z 完整反转</a:t>
-            </a:r>
-          </a:p>
-          <a:p>
-            <a:pPr>
-              <a:defRPr sz="1300">
-                <a:solidFill>
-                  <a:srgbClr val="202020"/>
-                </a:solidFill>
-              </a:defRPr>
-            </a:pPr>
-          </a:p>
-          <a:p>
-            <a:pPr>
-              <a:defRPr sz="1300">
+              <a:defRPr sz="2000">
+                <a:solidFill>
+                  <a:srgbClr val="202020"/>
+                </a:solidFill>
+              </a:defRPr>
+            </a:pPr>
+            <a:r>
+              <a:t>- 双向 FAILED：未观察到 +z → -z 完整反转</a:t>
+            </a:r>
+          </a:p>
+          <a:p>
+            <a:pPr>
+              <a:defRPr sz="2000">
+                <a:solidFill>
+                  <a:srgbClr val="202020"/>
+                </a:solidFill>
+              </a:defRPr>
+            </a:pPr>
+          </a:p>
+          <a:p>
+            <a:pPr>
+              <a:defRPr sz="2000">
                 <a:solidFill>
                   <a:srgbClr val="202020"/>
                 </a:solidFill>
@@ -6017,94 +5723,94 @@
           </a:p>
           <a:p>
             <a:pPr>
-              <a:defRPr sz="1300">
-                <a:solidFill>
-                  <a:srgbClr val="202020"/>
-                </a:solidFill>
-              </a:defRPr>
-            </a:pPr>
-            <a:r>
-              <a:t>- Phase1 100 GHz：0 → +17.6 nm（**PASS**）</a:t>
-            </a:r>
-          </a:p>
-          <a:p>
-            <a:pPr>
-              <a:defRPr sz="1300">
-                <a:solidFill>
-                  <a:srgbClr val="202020"/>
-                </a:solidFill>
-              </a:defRPr>
-            </a:pPr>
-            <a:r>
-              <a:t>- Phase2 1100 GHz：+17.6 nm → -12.9 nm（**反转 SUCCESS**）</a:t>
-            </a:r>
-          </a:p>
-          <a:p>
-            <a:pPr>
-              <a:defRPr sz="1300">
-                <a:solidFill>
-                  <a:srgbClr val="202020"/>
-                </a:solidFill>
-              </a:defRPr>
-            </a:pPr>
-            <a:r>
-              <a:t>- **t ≈ 0.91 ns Hopfion 拓扑结构坍塌，core=0**（毕设展示截到 0.80 ns，未提坍塌，本次完整呈现到 1.00 ns）</a:t>
-            </a:r>
-          </a:p>
-          <a:p>
-            <a:pPr>
-              <a:defRPr sz="1300">
-                <a:solidFill>
-                  <a:srgbClr val="202020"/>
-                </a:solidFill>
-              </a:defRPr>
-            </a:pPr>
-          </a:p>
-          <a:p>
-            <a:pPr>
-              <a:defRPr sz="1300">
-                <a:solidFill>
-                  <a:srgbClr val="202020"/>
-                </a:solidFill>
-              </a:defRPr>
-            </a:pPr>
-            <a:r>
-              <a:t>**失败根因**：1100 GHz 推 -z 力量过强（耦合 ~74 nm/ns，远超 Phase1 的 ~35 nm/ns），Phase2 持续 0.30 ns 形变累积过临界。</a:t>
-            </a:r>
-          </a:p>
-          <a:p>
-            <a:pPr>
-              <a:defRPr sz="1300">
-                <a:solidFill>
-                  <a:srgbClr val="202020"/>
-                </a:solidFill>
-              </a:defRPr>
-            </a:pPr>
-          </a:p>
-          <a:p>
-            <a:pPr>
-              <a:defRPr sz="1300">
-                <a:solidFill>
-                  <a:srgbClr val="202020"/>
-                </a:solidFill>
-              </a:defRPr>
-            </a:pPr>
-            <a:r>
-              <a:t>**方案 A 调参（未实施）**：Phase2 脉宽 → 0.05-0.10 ns；Phase2 振幅 → 0.3-0.5 T；后接 0 场维持。</a:t>
-            </a:r>
-          </a:p>
-          <a:p>
-            <a:pPr>
-              <a:defRPr sz="1300">
-                <a:solidFill>
-                  <a:srgbClr val="202020"/>
-                </a:solidFill>
-              </a:defRPr>
-            </a:pPr>
-          </a:p>
-          <a:p>
-            <a:pPr>
-              <a:defRPr sz="1300">
+              <a:defRPr sz="2000">
+                <a:solidFill>
+                  <a:srgbClr val="202020"/>
+                </a:solidFill>
+              </a:defRPr>
+            </a:pPr>
+            <a:r>
+              <a:t>- Phase1 100 GHz：0 → +17.6 nm（PASS）</a:t>
+            </a:r>
+          </a:p>
+          <a:p>
+            <a:pPr>
+              <a:defRPr sz="2000">
+                <a:solidFill>
+                  <a:srgbClr val="202020"/>
+                </a:solidFill>
+              </a:defRPr>
+            </a:pPr>
+            <a:r>
+              <a:t>- Phase2 1100 GHz：+17.6 nm → -12.9 nm（反转 SUCCESS）</a:t>
+            </a:r>
+          </a:p>
+          <a:p>
+            <a:pPr>
+              <a:defRPr sz="2000">
+                <a:solidFill>
+                  <a:srgbClr val="202020"/>
+                </a:solidFill>
+              </a:defRPr>
+            </a:pPr>
+            <a:r>
+              <a:t>- t ≈ 0.91 ns Hopfion 拓扑结构坍塌，core=0（毕设展示截到 0.80 ns，未提坍塌，本次完整呈现到 1.00 ns）</a:t>
+            </a:r>
+          </a:p>
+          <a:p>
+            <a:pPr>
+              <a:defRPr sz="2000">
+                <a:solidFill>
+                  <a:srgbClr val="202020"/>
+                </a:solidFill>
+              </a:defRPr>
+            </a:pPr>
+          </a:p>
+          <a:p>
+            <a:pPr>
+              <a:defRPr sz="2000">
+                <a:solidFill>
+                  <a:srgbClr val="202020"/>
+                </a:solidFill>
+              </a:defRPr>
+            </a:pPr>
+            <a:r>
+              <a:t>失败根因：1100 GHz 推 -z 力量过强（耦合 ~74 nm/ns，远超 Phase1 的 ~35 nm/ns），Phase2 持续 0.30 ns 形变累积过临界。</a:t>
+            </a:r>
+          </a:p>
+          <a:p>
+            <a:pPr>
+              <a:defRPr sz="2000">
+                <a:solidFill>
+                  <a:srgbClr val="202020"/>
+                </a:solidFill>
+              </a:defRPr>
+            </a:pPr>
+          </a:p>
+          <a:p>
+            <a:pPr>
+              <a:defRPr sz="2000">
+                <a:solidFill>
+                  <a:srgbClr val="202020"/>
+                </a:solidFill>
+              </a:defRPr>
+            </a:pPr>
+            <a:r>
+              <a:t>方案 A 调参（未实施）：Phase2 脉宽 → 0.05-0.10 ns；Phase2 振幅 → 0.3-0.5 T；后接 0 场维持。</a:t>
+            </a:r>
+          </a:p>
+          <a:p>
+            <a:pPr>
+              <a:defRPr sz="2000">
+                <a:solidFill>
+                  <a:srgbClr val="202020"/>
+                </a:solidFill>
+              </a:defRPr>
+            </a:pPr>
+          </a:p>
+          <a:p>
+            <a:pPr>
+              <a:defRPr sz="2000">
                 <a:solidFill>
                   <a:srgbClr val="202020"/>
                 </a:solidFill>
@@ -6112,27 +5818,6 @@
             </a:pPr>
             <a:r>
               <a:t>来源：`20260105_frustrated_fm/spin_wave_dynamics/multisource_control/bidirectional_z/`</a:t>
-            </a:r>
-          </a:p>
-          <a:p>
-            <a:pPr>
-              <a:defRPr sz="1300">
-                <a:solidFill>
-                  <a:srgbClr val="202020"/>
-                </a:solidFill>
-              </a:defRPr>
-            </a:pPr>
-          </a:p>
-          <a:p>
-            <a:pPr>
-              <a:defRPr sz="1300">
-                <a:solidFill>
-                  <a:srgbClr val="202020"/>
-                </a:solidFill>
-              </a:defRPr>
-            </a:pPr>
-            <a:r>
-              <a:t>---</a:t>
             </a:r>
           </a:p>
         </p:txBody>
@@ -6202,7 +5887,7 @@
           <a:lstStyle/>
           <a:p>
             <a:pPr>
-              <a:defRPr sz="2200" b="1">
+              <a:defRPr sz="2000" b="1">
                 <a:solidFill>
                   <a:srgbClr val="1F2D5A"/>
                 </a:solidFill>
@@ -6237,7 +5922,7 @@
           <a:lstStyle/>
           <a:p>
             <a:pPr>
-              <a:defRPr sz="1300">
+              <a:defRPr sz="2000">
                 <a:solidFill>
                   <a:srgbClr val="202020"/>
                 </a:solidFill>
@@ -6249,16 +5934,16 @@
           </a:p>
           <a:p>
             <a:pPr>
-              <a:defRPr sz="1300">
-                <a:solidFill>
-                  <a:srgbClr val="202020"/>
-                </a:solidFill>
-              </a:defRPr>
-            </a:pPr>
-          </a:p>
-          <a:p>
-            <a:pPr>
-              <a:defRPr sz="1300">
+              <a:defRPr sz="2000">
+                <a:solidFill>
+                  <a:srgbClr val="202020"/>
+                </a:solidFill>
+              </a:defRPr>
+            </a:pPr>
+          </a:p>
+          <a:p>
+            <a:pPr>
+              <a:defRPr sz="2000">
                 <a:solidFill>
                   <a:srgbClr val="202020"/>
                 </a:solidFill>
@@ -6270,7 +5955,7 @@
           </a:p>
           <a:p>
             <a:pPr>
-              <a:defRPr sz="1300">
+              <a:defRPr sz="2000">
                 <a:solidFill>
                   <a:srgbClr val="202020"/>
                 </a:solidFill>
@@ -6282,16 +5967,16 @@
           </a:p>
           <a:p>
             <a:pPr>
-              <a:defRPr sz="1300">
-                <a:solidFill>
-                  <a:srgbClr val="202020"/>
-                </a:solidFill>
-              </a:defRPr>
-            </a:pPr>
-          </a:p>
-          <a:p>
-            <a:pPr>
-              <a:defRPr sz="1300">
+              <a:defRPr sz="2000">
+                <a:solidFill>
+                  <a:srgbClr val="202020"/>
+                </a:solidFill>
+              </a:defRPr>
+            </a:pPr>
+          </a:p>
+          <a:p>
+            <a:pPr>
+              <a:defRPr sz="2000">
                 <a:solidFill>
                   <a:srgbClr val="202020"/>
                 </a:solidFill>
@@ -6303,16 +5988,16 @@
           </a:p>
           <a:p>
             <a:pPr>
-              <a:defRPr sz="1300">
-                <a:solidFill>
-                  <a:srgbClr val="202020"/>
-                </a:solidFill>
-              </a:defRPr>
-            </a:pPr>
-          </a:p>
-          <a:p>
-            <a:pPr>
-              <a:defRPr sz="1300">
+              <a:defRPr sz="2000">
+                <a:solidFill>
+                  <a:srgbClr val="202020"/>
+                </a:solidFill>
+              </a:defRPr>
+            </a:pPr>
+          </a:p>
+          <a:p>
+            <a:pPr>
+              <a:defRPr sz="2000">
                 <a:solidFill>
                   <a:srgbClr val="202020"/>
                 </a:solidFill>
@@ -6320,27 +6005,6 @@
             </a:pPr>
             <a:r>
               <a:t>无图。来源：`20260310_wang2019_hopfion_STT/`</a:t>
-            </a:r>
-          </a:p>
-          <a:p>
-            <a:pPr>
-              <a:defRPr sz="1300">
-                <a:solidFill>
-                  <a:srgbClr val="202020"/>
-                </a:solidFill>
-              </a:defRPr>
-            </a:pPr>
-          </a:p>
-          <a:p>
-            <a:pPr>
-              <a:defRPr sz="1300">
-                <a:solidFill>
-                  <a:srgbClr val="202020"/>
-                </a:solidFill>
-              </a:defRPr>
-            </a:pPr>
-            <a:r>
-              <a:t>---</a:t>
             </a:r>
           </a:p>
         </p:txBody>
@@ -6386,7 +6050,7 @@
           <a:lstStyle/>
           <a:p>
             <a:pPr>
-              <a:defRPr sz="2200" b="1">
+              <a:defRPr sz="2000" b="1">
                 <a:solidFill>
                   <a:srgbClr val="1F2D5A"/>
                 </a:solidFill>
@@ -6421,7 +6085,7 @@
           <a:lstStyle/>
           <a:p>
             <a:pPr>
-              <a:defRPr sz="1300">
+              <a:defRPr sz="2000">
                 <a:solidFill>
                   <a:srgbClr val="202020"/>
                 </a:solidFill>
@@ -6433,16 +6097,16 @@
           </a:p>
           <a:p>
             <a:pPr>
-              <a:defRPr sz="1300">
-                <a:solidFill>
-                  <a:srgbClr val="202020"/>
-                </a:solidFill>
-              </a:defRPr>
-            </a:pPr>
-          </a:p>
-          <a:p>
-            <a:pPr>
-              <a:defRPr sz="1300">
+              <a:defRPr sz="2000">
+                <a:solidFill>
+                  <a:srgbClr val="202020"/>
+                </a:solidFill>
+              </a:defRPr>
+            </a:pPr>
+          </a:p>
+          <a:p>
+            <a:pPr>
+              <a:defRPr sz="2000">
                 <a:solidFill>
                   <a:srgbClr val="202020"/>
                 </a:solidFill>
@@ -6454,7 +6118,7 @@
           </a:p>
           <a:p>
             <a:pPr>
-              <a:defRPr sz="1300">
+              <a:defRPr sz="2000">
                 <a:solidFill>
                   <a:srgbClr val="202020"/>
                 </a:solidFill>
@@ -6466,28 +6130,28 @@
           </a:p>
           <a:p>
             <a:pPr>
-              <a:defRPr sz="1300">
-                <a:solidFill>
-                  <a:srgbClr val="202020"/>
-                </a:solidFill>
-              </a:defRPr>
-            </a:pPr>
-          </a:p>
-          <a:p>
-            <a:pPr>
-              <a:defRPr sz="1300">
-                <a:solidFill>
-                  <a:srgbClr val="202020"/>
-                </a:solidFill>
-              </a:defRPr>
-            </a:pPr>
-            <a:r>
-              <a:t>**结论 PASS**：</a:t>
-            </a:r>
-          </a:p>
-          <a:p>
-            <a:pPr>
-              <a:defRPr sz="1300">
+              <a:defRPr sz="2000">
+                <a:solidFill>
+                  <a:srgbClr val="202020"/>
+                </a:solidFill>
+              </a:defRPr>
+            </a:pPr>
+          </a:p>
+          <a:p>
+            <a:pPr>
+              <a:defRPr sz="2000">
+                <a:solidFill>
+                  <a:srgbClr val="202020"/>
+                </a:solidFill>
+              </a:defRPr>
+            </a:pPr>
+            <a:r>
+              <a:t>结论 PASS：</a:t>
+            </a:r>
+          </a:p>
+          <a:p>
+            <a:pPr>
+              <a:defRPr sz="2000">
                 <a:solidFill>
                   <a:srgbClr val="202020"/>
                 </a:solidFill>
@@ -6499,7 +6163,7 @@
           </a:p>
           <a:p>
             <a:pPr>
-              <a:defRPr sz="1300">
+              <a:defRPr sz="2000">
                 <a:solidFill>
                   <a:srgbClr val="202020"/>
                 </a:solidFill>
@@ -6511,7 +6175,7 @@
           </a:p>
           <a:p>
             <a:pPr>
-              <a:defRPr sz="1300">
+              <a:defRPr sz="2000">
                 <a:solidFill>
                   <a:srgbClr val="202020"/>
                 </a:solidFill>
@@ -6523,37 +6187,37 @@
           </a:p>
           <a:p>
             <a:pPr>
-              <a:defRPr sz="1300">
-                <a:solidFill>
-                  <a:srgbClr val="202020"/>
-                </a:solidFill>
-              </a:defRPr>
-            </a:pPr>
-          </a:p>
-          <a:p>
-            <a:pPr>
-              <a:defRPr sz="1300">
-                <a:solidFill>
-                  <a:srgbClr val="202020"/>
-                </a:solidFill>
-              </a:defRPr>
-            </a:pPr>
-            <a:r>
-              <a:t>**意外发现**：Hopfion **偏好低 Ku 区**（gradient 平衡在 Ku≈7500 端，即 +z 端），与初始假设"Hopfion 趋向高 Ku 区"**相反**。Phase 2 设计因此需要反转源-初态位置。</a:t>
-            </a:r>
-          </a:p>
-          <a:p>
-            <a:pPr>
-              <a:defRPr sz="1300">
-                <a:solidFill>
-                  <a:srgbClr val="202020"/>
-                </a:solidFill>
-              </a:defRPr>
-            </a:pPr>
-          </a:p>
-          <a:p>
-            <a:pPr>
-              <a:defRPr sz="1300">
+              <a:defRPr sz="2000">
+                <a:solidFill>
+                  <a:srgbClr val="202020"/>
+                </a:solidFill>
+              </a:defRPr>
+            </a:pPr>
+          </a:p>
+          <a:p>
+            <a:pPr>
+              <a:defRPr sz="2000">
+                <a:solidFill>
+                  <a:srgbClr val="202020"/>
+                </a:solidFill>
+              </a:defRPr>
+            </a:pPr>
+            <a:r>
+              <a:t>意外发现：Hopfion 偏好低 Ku 区（gradient 平衡在 Ku≈7500 端，即 +z 端），与初始假设"Hopfion 趋向高 Ku 区"相反。Phase 2 设计因此需要反转源-初态位置。</a:t>
+            </a:r>
+          </a:p>
+          <a:p>
+            <a:pPr>
+              <a:defRPr sz="2000">
+                <a:solidFill>
+                  <a:srgbClr val="202020"/>
+                </a:solidFill>
+              </a:defRPr>
+            </a:pPr>
+          </a:p>
+          <a:p>
+            <a:pPr>
+              <a:defRPr sz="2000">
                 <a:solidFill>
                   <a:srgbClr val="202020"/>
                 </a:solidFill>
@@ -6561,27 +6225,6 @@
             </a:pPr>
             <a:r>
               <a:t>来源：`lif_neuron_hopfion/gradient_ku_verification/drive_release_test/`</a:t>
-            </a:r>
-          </a:p>
-          <a:p>
-            <a:pPr>
-              <a:defRPr sz="1300">
-                <a:solidFill>
-                  <a:srgbClr val="202020"/>
-                </a:solidFill>
-              </a:defRPr>
-            </a:pPr>
-          </a:p>
-          <a:p>
-            <a:pPr>
-              <a:defRPr sz="1300">
-                <a:solidFill>
-                  <a:srgbClr val="202020"/>
-                </a:solidFill>
-              </a:defRPr>
-            </a:pPr>
-            <a:r>
-              <a:t>---</a:t>
             </a:r>
           </a:p>
         </p:txBody>
@@ -6651,7 +6294,7 @@
           <a:lstStyle/>
           <a:p>
             <a:pPr>
-              <a:defRPr sz="2200" b="1">
+              <a:defRPr sz="2000" b="1">
                 <a:solidFill>
                   <a:srgbClr val="1F2D5A"/>
                 </a:solidFill>
@@ -6686,7 +6329,7 @@
           <a:lstStyle/>
           <a:p>
             <a:pPr>
-              <a:defRPr sz="1300">
+              <a:defRPr sz="2000">
                 <a:solidFill>
                   <a:srgbClr val="202020"/>
                 </a:solidFill>
@@ -6698,37 +6341,37 @@
           </a:p>
           <a:p>
             <a:pPr>
-              <a:defRPr sz="1300">
-                <a:solidFill>
-                  <a:srgbClr val="202020"/>
-                </a:solidFill>
-              </a:defRPr>
-            </a:pPr>
-          </a:p>
-          <a:p>
-            <a:pPr>
-              <a:defRPr sz="1300">
-                <a:solidFill>
-                  <a:srgbClr val="202020"/>
-                </a:solidFill>
-              </a:defRPr>
-            </a:pPr>
-            <a:r>
-              <a:t>**FAILED**，t=1.089 ns kill（6h49m 跑了 49.5%）。</a:t>
-            </a:r>
-          </a:p>
-          <a:p>
-            <a:pPr>
-              <a:defRPr sz="1300">
-                <a:solidFill>
-                  <a:srgbClr val="202020"/>
-                </a:solidFill>
-              </a:defRPr>
-            </a:pPr>
-          </a:p>
-          <a:p>
-            <a:pPr>
-              <a:defRPr sz="1300">
+              <a:defRPr sz="2000">
+                <a:solidFill>
+                  <a:srgbClr val="202020"/>
+                </a:solidFill>
+              </a:defRPr>
+            </a:pPr>
+          </a:p>
+          <a:p>
+            <a:pPr>
+              <a:defRPr sz="2000">
+                <a:solidFill>
+                  <a:srgbClr val="202020"/>
+                </a:solidFill>
+              </a:defRPr>
+            </a:pPr>
+            <a:r>
+              <a:t>FAILED，t=1.089 ns kill（6h49m 跑了 49.5%）。</a:t>
+            </a:r>
+          </a:p>
+          <a:p>
+            <a:pPr>
+              <a:defRPr sz="2000">
+                <a:solidFill>
+                  <a:srgbClr val="202020"/>
+                </a:solidFill>
+              </a:defRPr>
+            </a:pPr>
+          </a:p>
+          <a:p>
+            <a:pPr>
+              <a:defRPr sz="2000">
                 <a:solidFill>
                   <a:srgbClr val="202020"/>
                 </a:solidFill>
@@ -6740,40 +6383,40 @@
           </a:p>
           <a:p>
             <a:pPr>
-              <a:defRPr sz="1300">
-                <a:solidFill>
-                  <a:srgbClr val="202020"/>
-                </a:solidFill>
-              </a:defRPr>
-            </a:pPr>
-          </a:p>
-          <a:p>
-            <a:pPr>
-              <a:defRPr sz="1300">
-                <a:solidFill>
-                  <a:srgbClr val="202020"/>
-                </a:solidFill>
-              </a:defRPr>
-            </a:pPr>
-            <a:r>
-              <a:t>**失败原因**：</a:t>
-            </a:r>
-          </a:p>
-          <a:p>
-            <a:pPr>
-              <a:defRPr sz="1300">
-                <a:solidFill>
-                  <a:srgbClr val="202020"/>
-                </a:solidFill>
-              </a:defRPr>
-            </a:pPr>
-            <a:r>
-              <a:t>1. 1100 GHz 推 -z 方向，与梯度 Ku 恢复力 +z **同向**（不是反向），Hopfion 单向漂移</a:t>
-            </a:r>
-          </a:p>
-          <a:p>
-            <a:pPr>
-              <a:defRPr sz="1300">
+              <a:defRPr sz="2000">
+                <a:solidFill>
+                  <a:srgbClr val="202020"/>
+                </a:solidFill>
+              </a:defRPr>
+            </a:pPr>
+          </a:p>
+          <a:p>
+            <a:pPr>
+              <a:defRPr sz="2000">
+                <a:solidFill>
+                  <a:srgbClr val="202020"/>
+                </a:solidFill>
+              </a:defRPr>
+            </a:pPr>
+            <a:r>
+              <a:t>失败原因：</a:t>
+            </a:r>
+          </a:p>
+          <a:p>
+            <a:pPr>
+              <a:defRPr sz="2000">
+                <a:solidFill>
+                  <a:srgbClr val="202020"/>
+                </a:solidFill>
+              </a:defRPr>
+            </a:pPr>
+            <a:r>
+              <a:t>1. 1100 GHz 推 -z 方向，与梯度 Ku 恢复力 +z 同向（不是反向），Hopfion 单向漂移</a:t>
+            </a:r>
+          </a:p>
+          <a:p>
+            <a:pPr>
+              <a:defRPr sz="2000">
                 <a:solidFill>
                   <a:srgbClr val="202020"/>
                 </a:solidFill>
@@ -6785,7 +6428,7 @@
           </a:p>
           <a:p>
             <a:pPr>
-              <a:defRPr sz="1300">
+              <a:defRPr sz="2000">
                 <a:solidFill>
                   <a:srgbClr val="202020"/>
                 </a:solidFill>
@@ -6797,16 +6440,16 @@
           </a:p>
           <a:p>
             <a:pPr>
-              <a:defRPr sz="1300">
-                <a:solidFill>
-                  <a:srgbClr val="202020"/>
-                </a:solidFill>
-              </a:defRPr>
-            </a:pPr>
-          </a:p>
-          <a:p>
-            <a:pPr>
-              <a:defRPr sz="1300">
+              <a:defRPr sz="2000">
+                <a:solidFill>
+                  <a:srgbClr val="202020"/>
+                </a:solidFill>
+              </a:defRPr>
+            </a:pPr>
+          </a:p>
+          <a:p>
+            <a:pPr>
+              <a:defRPr sz="2000">
                 <a:solidFill>
                   <a:srgbClr val="202020"/>
                 </a:solidFill>
@@ -6814,27 +6457,6 @@
             </a:pPr>
             <a:r>
               <a:t>来源：`lif_neuron_hopfion/lif_cycle_demo/pulse_train_integrate/`</a:t>
-            </a:r>
-          </a:p>
-          <a:p>
-            <a:pPr>
-              <a:defRPr sz="1300">
-                <a:solidFill>
-                  <a:srgbClr val="202020"/>
-                </a:solidFill>
-              </a:defRPr>
-            </a:pPr>
-          </a:p>
-          <a:p>
-            <a:pPr>
-              <a:defRPr sz="1300">
-                <a:solidFill>
-                  <a:srgbClr val="202020"/>
-                </a:solidFill>
-              </a:defRPr>
-            </a:pPr>
-            <a:r>
-              <a:t>---</a:t>
             </a:r>
           </a:p>
         </p:txBody>
@@ -6904,7 +6526,7 @@
           <a:lstStyle/>
           <a:p>
             <a:pPr>
-              <a:defRPr sz="2200" b="1">
+              <a:defRPr sz="2000" b="1">
                 <a:solidFill>
                   <a:srgbClr val="1F2D5A"/>
                 </a:solidFill>
@@ -6939,7 +6561,7 @@
           <a:lstStyle/>
           <a:p>
             <a:pPr>
-              <a:defRPr sz="1300">
+              <a:defRPr sz="2000">
                 <a:solidFill>
                   <a:srgbClr val="202020"/>
                 </a:solidFill>
@@ -6951,64 +6573,64 @@
           </a:p>
           <a:p>
             <a:pPr>
-              <a:defRPr sz="1300">
-                <a:solidFill>
-                  <a:srgbClr val="202020"/>
-                </a:solidFill>
-              </a:defRPr>
-            </a:pPr>
-            <a:r>
-              <a:t>- **方案 A**：反转源-初态相对位置（initial 在 -z 端高 Ku，integrate 用 100 GHz → +z，梯度自然拉回 -z，fire 用反向冲击）</a:t>
-            </a:r>
-          </a:p>
-          <a:p>
-            <a:pPr>
-              <a:defRPr sz="1300">
-                <a:solidFill>
-                  <a:srgbClr val="202020"/>
-                </a:solidFill>
-              </a:defRPr>
-            </a:pPr>
-            <a:r>
-              <a:t>- **方案 B**：降低 1100 GHz 幅度（B=0.3 T） + 延长 leak gap（0.5 ns）让自旋波耗散</a:t>
-            </a:r>
-          </a:p>
-          <a:p>
-            <a:pPr>
-              <a:defRPr sz="1300">
-                <a:solidFill>
-                  <a:srgbClr val="202020"/>
-                </a:solidFill>
-              </a:defRPr>
-            </a:pPr>
-            <a:r>
-              <a:t>- **方案 C**：缩短 pulse 宽（0.15 → 0.05 ns）减少单次注入能量</a:t>
-            </a:r>
-          </a:p>
-          <a:p>
-            <a:pPr>
-              <a:defRPr sz="1300">
-                <a:solidFill>
-                  <a:srgbClr val="202020"/>
-                </a:solidFill>
-              </a:defRPr>
-            </a:pPr>
-            <a:r>
-              <a:t>- **方案 D**：双频叠加 integrate（1100 GHz 短冲 + 立即 100 GHz 反向短冲抑制残余自旋波）</a:t>
-            </a:r>
-          </a:p>
-          <a:p>
-            <a:pPr>
-              <a:defRPr sz="1300">
-                <a:solidFill>
-                  <a:srgbClr val="202020"/>
-                </a:solidFill>
-              </a:defRPr>
-            </a:pPr>
-          </a:p>
-          <a:p>
-            <a:pPr>
-              <a:defRPr sz="1300">
+              <a:defRPr sz="2000">
+                <a:solidFill>
+                  <a:srgbClr val="202020"/>
+                </a:solidFill>
+              </a:defRPr>
+            </a:pPr>
+            <a:r>
+              <a:t>- 方案 A：反转源-初态相对位置（initial 在 -z 端高 Ku，integrate 用 100 GHz → +z，梯度自然拉回 -z，fire 用反向冲击）</a:t>
+            </a:r>
+          </a:p>
+          <a:p>
+            <a:pPr>
+              <a:defRPr sz="2000">
+                <a:solidFill>
+                  <a:srgbClr val="202020"/>
+                </a:solidFill>
+              </a:defRPr>
+            </a:pPr>
+            <a:r>
+              <a:t>- 方案 B：降低 1100 GHz 幅度（B=0.3 T） + 延长 leak gap（0.5 ns）让自旋波耗散</a:t>
+            </a:r>
+          </a:p>
+          <a:p>
+            <a:pPr>
+              <a:defRPr sz="2000">
+                <a:solidFill>
+                  <a:srgbClr val="202020"/>
+                </a:solidFill>
+              </a:defRPr>
+            </a:pPr>
+            <a:r>
+              <a:t>- 方案 C：缩短 pulse 宽（0.15 → 0.05 ns）减少单次注入能量</a:t>
+            </a:r>
+          </a:p>
+          <a:p>
+            <a:pPr>
+              <a:defRPr sz="2000">
+                <a:solidFill>
+                  <a:srgbClr val="202020"/>
+                </a:solidFill>
+              </a:defRPr>
+            </a:pPr>
+            <a:r>
+              <a:t>- 方案 D：双频叠加 integrate（1100 GHz 短冲 + 立即 100 GHz 反向短冲抑制残余自旋波）</a:t>
+            </a:r>
+          </a:p>
+          <a:p>
+            <a:pPr>
+              <a:defRPr sz="2000">
+                <a:solidFill>
+                  <a:srgbClr val="202020"/>
+                </a:solidFill>
+              </a:defRPr>
+            </a:pPr>
+          </a:p>
+          <a:p>
+            <a:pPr>
+              <a:defRPr sz="2000">
                 <a:solidFill>
                   <a:srgbClr val="202020"/>
                 </a:solidFill>
@@ -7020,16 +6642,16 @@
           </a:p>
           <a:p>
             <a:pPr>
-              <a:defRPr sz="1300">
-                <a:solidFill>
-                  <a:srgbClr val="202020"/>
-                </a:solidFill>
-              </a:defRPr>
-            </a:pPr>
-          </a:p>
-          <a:p>
-            <a:pPr>
-              <a:defRPr sz="1300">
+              <a:defRPr sz="2000">
+                <a:solidFill>
+                  <a:srgbClr val="202020"/>
+                </a:solidFill>
+              </a:defRPr>
+            </a:pPr>
+          </a:p>
+          <a:p>
+            <a:pPr>
+              <a:defRPr sz="2000">
                 <a:solidFill>
                   <a:srgbClr val="202020"/>
                 </a:solidFill>
@@ -7041,16 +6663,16 @@
           </a:p>
           <a:p>
             <a:pPr>
-              <a:defRPr sz="1300">
-                <a:solidFill>
-                  <a:srgbClr val="202020"/>
-                </a:solidFill>
-              </a:defRPr>
-            </a:pPr>
-          </a:p>
-          <a:p>
-            <a:pPr>
-              <a:defRPr sz="1300">
+              <a:defRPr sz="2000">
+                <a:solidFill>
+                  <a:srgbClr val="202020"/>
+                </a:solidFill>
+              </a:defRPr>
+            </a:pPr>
+          </a:p>
+          <a:p>
+            <a:pPr>
+              <a:defRPr sz="2000">
                 <a:solidFill>
                   <a:srgbClr val="202020"/>
                 </a:solidFill>
@@ -7058,27 +6680,6 @@
             </a:pPr>
             <a:r>
               <a:t>无图。来源：`lif_neuron_hopfion/lif_cycle_demo/`（脚本就绪）</a:t>
-            </a:r>
-          </a:p>
-          <a:p>
-            <a:pPr>
-              <a:defRPr sz="1300">
-                <a:solidFill>
-                  <a:srgbClr val="202020"/>
-                </a:solidFill>
-              </a:defRPr>
-            </a:pPr>
-          </a:p>
-          <a:p>
-            <a:pPr>
-              <a:defRPr sz="1300">
-                <a:solidFill>
-                  <a:srgbClr val="202020"/>
-                </a:solidFill>
-              </a:defRPr>
-            </a:pPr>
-            <a:r>
-              <a:t>---</a:t>
             </a:r>
           </a:p>
         </p:txBody>
@@ -7124,7 +6725,7 @@
           <a:lstStyle/>
           <a:p>
             <a:pPr>
-              <a:defRPr sz="2200" b="1">
+              <a:defRPr sz="2000" b="1">
                 <a:solidFill>
                   <a:srgbClr val="1F2D5A"/>
                 </a:solidFill>
@@ -7159,28 +6760,28 @@
           <a:lstStyle/>
           <a:p>
             <a:pPr>
-              <a:defRPr sz="1300">
-                <a:solidFill>
-                  <a:srgbClr val="202020"/>
-                </a:solidFill>
-              </a:defRPr>
-            </a:pPr>
-            <a:r>
-              <a:t>old_results/My_old_simulation/ 共 20 个 srcX/srcZ point source freq sweep。**含 J2/J4 系数符号错误**。</a:t>
-            </a:r>
-          </a:p>
-          <a:p>
-            <a:pPr>
-              <a:defRPr sz="1300">
-                <a:solidFill>
-                  <a:srgbClr val="202020"/>
-                </a:solidFill>
-              </a:defRPr>
-            </a:pPr>
-          </a:p>
-          <a:p>
-            <a:pPr>
-              <a:defRPr sz="1300">
+              <a:defRPr sz="2000">
+                <a:solidFill>
+                  <a:srgbClr val="202020"/>
+                </a:solidFill>
+              </a:defRPr>
+            </a:pPr>
+            <a:r>
+              <a:t>old_results/My_old_simulation/ 共 20 个 srcX/srcZ point source freq sweep。含 J2/J4 系数符号错误。</a:t>
+            </a:r>
+          </a:p>
+          <a:p>
+            <a:pPr>
+              <a:defRPr sz="2000">
+                <a:solidFill>
+                  <a:srgbClr val="202020"/>
+                </a:solidFill>
+              </a:defRPr>
+            </a:pPr>
+          </a:p>
+          <a:p>
+            <a:pPr>
+              <a:defRPr sz="2000">
                 <a:solidFill>
                   <a:srgbClr val="202020"/>
                 </a:solidFill>
@@ -7192,16 +6793,16 @@
           </a:p>
           <a:p>
             <a:pPr>
-              <a:defRPr sz="1300">
-                <a:solidFill>
-                  <a:srgbClr val="202020"/>
-                </a:solidFill>
-              </a:defRPr>
-            </a:pPr>
-          </a:p>
-          <a:p>
-            <a:pPr>
-              <a:defRPr sz="1300">
+              <a:defRPr sz="2000">
+                <a:solidFill>
+                  <a:srgbClr val="202020"/>
+                </a:solidFill>
+              </a:defRPr>
+            </a:pPr>
+          </a:p>
+          <a:p>
+            <a:pPr>
+              <a:defRPr sz="2000">
                 <a:solidFill>
                   <a:srgbClr val="202020"/>
                 </a:solidFill>
@@ -7213,37 +6814,37 @@
           </a:p>
           <a:p>
             <a:pPr>
-              <a:defRPr sz="1300">
-                <a:solidFill>
-                  <a:srgbClr val="202020"/>
-                </a:solidFill>
-              </a:defRPr>
-            </a:pPr>
-          </a:p>
-          <a:p>
-            <a:pPr>
-              <a:defRPr sz="1300">
-                <a:solidFill>
-                  <a:srgbClr val="202020"/>
-                </a:solidFill>
-              </a:defRPr>
-            </a:pPr>
-            <a:r>
-              <a:t>**经验**：复用别人代码时必须验证符号；从已验证的 R8r4_Ku0.mx3 拷参数，不要从公式重推。</a:t>
-            </a:r>
-          </a:p>
-          <a:p>
-            <a:pPr>
-              <a:defRPr sz="1300">
-                <a:solidFill>
-                  <a:srgbClr val="202020"/>
-                </a:solidFill>
-              </a:defRPr>
-            </a:pPr>
-          </a:p>
-          <a:p>
-            <a:pPr>
-              <a:defRPr sz="1300">
+              <a:defRPr sz="2000">
+                <a:solidFill>
+                  <a:srgbClr val="202020"/>
+                </a:solidFill>
+              </a:defRPr>
+            </a:pPr>
+          </a:p>
+          <a:p>
+            <a:pPr>
+              <a:defRPr sz="2000">
+                <a:solidFill>
+                  <a:srgbClr val="202020"/>
+                </a:solidFill>
+              </a:defRPr>
+            </a:pPr>
+            <a:r>
+              <a:t>经验：复用别人代码时必须验证符号；从已验证的 R8r4_Ku0.mx3 拷参数，不要从公式重推。</a:t>
+            </a:r>
+          </a:p>
+          <a:p>
+            <a:pPr>
+              <a:defRPr sz="2000">
+                <a:solidFill>
+                  <a:srgbClr val="202020"/>
+                </a:solidFill>
+              </a:defRPr>
+            </a:pPr>
+          </a:p>
+          <a:p>
+            <a:pPr>
+              <a:defRPr sz="2000">
                 <a:solidFill>
                   <a:srgbClr val="202020"/>
                 </a:solidFill>
@@ -7251,27 +6852,6 @@
             </a:pPr>
             <a:r>
               <a:t>无图。来源：`old_results/My_old_simulation/A材料尺寸对hopfion的影响/`</a:t>
-            </a:r>
-          </a:p>
-          <a:p>
-            <a:pPr>
-              <a:defRPr sz="1300">
-                <a:solidFill>
-                  <a:srgbClr val="202020"/>
-                </a:solidFill>
-              </a:defRPr>
-            </a:pPr>
-          </a:p>
-          <a:p>
-            <a:pPr>
-              <a:defRPr sz="1300">
-                <a:solidFill>
-                  <a:srgbClr val="202020"/>
-                </a:solidFill>
-              </a:defRPr>
-            </a:pPr>
-            <a:r>
-              <a:t>---</a:t>
             </a:r>
           </a:p>
         </p:txBody>
@@ -7317,7 +6897,7 @@
           <a:lstStyle/>
           <a:p>
             <a:pPr>
-              <a:defRPr sz="2200" b="1">
+              <a:defRPr sz="2000" b="1">
                 <a:solidFill>
                   <a:srgbClr val="1F2D5A"/>
                 </a:solidFill>
@@ -7352,7 +6932,7 @@
           <a:lstStyle/>
           <a:p>
             <a:pPr>
-              <a:defRPr sz="1300">
+              <a:defRPr sz="2000">
                 <a:solidFill>
                   <a:srgbClr val="202020"/>
                 </a:solidFill>
@@ -7364,16 +6944,16 @@
           </a:p>
           <a:p>
             <a:pPr>
-              <a:defRPr sz="1300">
-                <a:solidFill>
-                  <a:srgbClr val="202020"/>
-                </a:solidFill>
-              </a:defRPr>
-            </a:pPr>
-          </a:p>
-          <a:p>
-            <a:pPr>
-              <a:defRPr sz="1300">
+              <a:defRPr sz="2000">
+                <a:solidFill>
+                  <a:srgbClr val="202020"/>
+                </a:solidFill>
+              </a:defRPr>
+            </a:pPr>
+          </a:p>
+          <a:p>
+            <a:pPr>
+              <a:defRPr sz="2000">
                 <a:solidFill>
                   <a:srgbClr val="202020"/>
                 </a:solidFill>
@@ -7385,7 +6965,7 @@
           </a:p>
           <a:p>
             <a:pPr>
-              <a:defRPr sz="1300">
+              <a:defRPr sz="2000">
                 <a:solidFill>
                   <a:srgbClr val="202020"/>
                 </a:solidFill>
@@ -7397,7 +6977,7 @@
           </a:p>
           <a:p>
             <a:pPr>
-              <a:defRPr sz="1300">
+              <a:defRPr sz="2000">
                 <a:solidFill>
                   <a:srgbClr val="202020"/>
                 </a:solidFill>
@@ -7409,7 +6989,7 @@
           </a:p>
           <a:p>
             <a:pPr>
-              <a:defRPr sz="1300">
+              <a:defRPr sz="2000">
                 <a:solidFill>
                   <a:srgbClr val="202020"/>
                 </a:solidFill>
@@ -7421,7 +7001,7 @@
           </a:p>
           <a:p>
             <a:pPr>
-              <a:defRPr sz="1300">
+              <a:defRPr sz="2000">
                 <a:solidFill>
                   <a:srgbClr val="202020"/>
                 </a:solidFill>
@@ -7433,16 +7013,16 @@
           </a:p>
           <a:p>
             <a:pPr>
-              <a:defRPr sz="1300">
-                <a:solidFill>
-                  <a:srgbClr val="202020"/>
-                </a:solidFill>
-              </a:defRPr>
-            </a:pPr>
-          </a:p>
-          <a:p>
-            <a:pPr>
-              <a:defRPr sz="1300">
+              <a:defRPr sz="2000">
+                <a:solidFill>
+                  <a:srgbClr val="202020"/>
+                </a:solidFill>
+              </a:defRPr>
+            </a:pPr>
+          </a:p>
+          <a:p>
+            <a:pPr>
+              <a:defRPr sz="2000">
                 <a:solidFill>
                   <a:srgbClr val="202020"/>
                 </a:solidFill>
@@ -7454,16 +7034,16 @@
           </a:p>
           <a:p>
             <a:pPr>
-              <a:defRPr sz="1300">
-                <a:solidFill>
-                  <a:srgbClr val="202020"/>
-                </a:solidFill>
-              </a:defRPr>
-            </a:pPr>
-          </a:p>
-          <a:p>
-            <a:pPr>
-              <a:defRPr sz="1300">
+              <a:defRPr sz="2000">
+                <a:solidFill>
+                  <a:srgbClr val="202020"/>
+                </a:solidFill>
+              </a:defRPr>
+            </a:pPr>
+          </a:p>
+          <a:p>
+            <a:pPr>
+              <a:defRPr sz="2000">
                 <a:solidFill>
                   <a:srgbClr val="202020"/>
                 </a:solidFill>
@@ -7471,27 +7051,6 @@
             </a:pPr>
             <a:r>
               <a:t>无图。来源：`deviceB_package/`、`srtp/`</a:t>
-            </a:r>
-          </a:p>
-          <a:p>
-            <a:pPr>
-              <a:defRPr sz="1300">
-                <a:solidFill>
-                  <a:srgbClr val="202020"/>
-                </a:solidFill>
-              </a:defRPr>
-            </a:pPr>
-          </a:p>
-          <a:p>
-            <a:pPr>
-              <a:defRPr sz="1300">
-                <a:solidFill>
-                  <a:srgbClr val="202020"/>
-                </a:solidFill>
-              </a:defRPr>
-            </a:pPr>
-            <a:r>
-              <a:t>---</a:t>
             </a:r>
           </a:p>
         </p:txBody>
@@ -7537,7 +7096,7 @@
           <a:lstStyle/>
           <a:p>
             <a:pPr>
-              <a:defRPr sz="2200" b="1">
+              <a:defRPr sz="2000" b="1">
                 <a:solidFill>
                   <a:srgbClr val="1F2D5A"/>
                 </a:solidFill>
@@ -7572,91 +7131,91 @@
           <a:lstStyle/>
           <a:p>
             <a:pPr>
-              <a:defRPr sz="1300">
-                <a:solidFill>
-                  <a:srgbClr val="202020"/>
-                </a:solidFill>
-              </a:defRPr>
-            </a:pPr>
-            <a:r>
-              <a:t>**跑完且有清晰结论**：DMI-FM 三条件稳定性 / Frustrated FM 固有吸引子 R=2.60 nm / 居中稳态 Ku 三组 / Ku 临界趋势 / Q_H=1 验证 / 漂移机理修正 / 方向选择性 vibX/vibZ / srcX/srcZ 频率响应 / 单源双向 z 可控性 / 点源 vs 平面源对比 / LIF Phase 1 梯度恢复力 + Hopfion 偏好低 Ku</a:t>
-            </a:r>
-          </a:p>
-          <a:p>
-            <a:pPr>
-              <a:defRPr sz="1300">
-                <a:solidFill>
-                  <a:srgbClr val="202020"/>
-                </a:solidFill>
-              </a:defRPr>
-            </a:pPr>
-          </a:p>
-          <a:p>
-            <a:pPr>
-              <a:defRPr sz="1300">
-                <a:solidFill>
-                  <a:srgbClr val="202020"/>
-                </a:solidFill>
-              </a:defRPr>
-            </a:pPr>
-            <a:r>
-              <a:t>**跑完但未归纳完整结论**：amplitude_sweep srcX 旧标度律已推翻、新拟合未确定 / freq_switch v3 反转成功但坍塌后无后续 / STT 复现仅趋势确认无定量扫描</a:t>
-            </a:r>
-          </a:p>
-          <a:p>
-            <a:pPr>
-              <a:defRPr sz="1300">
-                <a:solidFill>
-                  <a:srgbClr val="202020"/>
-                </a:solidFill>
-              </a:defRPr>
-            </a:pPr>
-          </a:p>
-          <a:p>
-            <a:pPr>
-              <a:defRPr sz="1300">
-                <a:solidFill>
-                  <a:srgbClr val="202020"/>
-                </a:solidFill>
-              </a:defRPr>
-            </a:pPr>
-            <a:r>
-              <a:t>**停在半路**：amplitude_sweep srcZ cron 部分缺失 / amplitude_sweep point B500 停在 0.433 ns / freq_switch v3 坍塌后未续 / LIF Phase 2 F1 在 1.089 ns kill</a:t>
-            </a:r>
-          </a:p>
-          <a:p>
-            <a:pPr>
-              <a:defRPr sz="1300">
-                <a:solidFill>
-                  <a:srgbClr val="202020"/>
-                </a:solidFill>
-              </a:defRPr>
-            </a:pPr>
-          </a:p>
-          <a:p>
-            <a:pPr>
-              <a:defRPr sz="1300">
-                <a:solidFill>
-                  <a:srgbClr val="202020"/>
-                </a:solidFill>
-              </a:defRPr>
-            </a:pPr>
-            <a:r>
-              <a:t>**从未启动**：Q_H=2 / Q_H=4 稳定性验证 / freq_switch v3 方案 A 调参 / LIF Phase 2 重设计 4 候选 / Wang 2019 STT 参数扫描深化</a:t>
-            </a:r>
-          </a:p>
-          <a:p>
-            <a:pPr>
-              <a:defRPr sz="1300">
-                <a:solidFill>
-                  <a:srgbClr val="202020"/>
-                </a:solidFill>
-              </a:defRPr>
-            </a:pPr>
-          </a:p>
-          <a:p>
-            <a:pPr>
-              <a:defRPr sz="1300">
+              <a:defRPr sz="2000">
+                <a:solidFill>
+                  <a:srgbClr val="202020"/>
+                </a:solidFill>
+              </a:defRPr>
+            </a:pPr>
+            <a:r>
+              <a:t>跑完且有清晰结论：DMI-FM 三条件稳定性 / Frustrated FM 固有吸引子 R=2.60 nm / 居中稳态 Ku 三组 / Ku 临界趋势 / Q_H=1 验证 / 漂移机理修正 / 方向选择性 vibX/vibZ / srcX/srcZ 频率响应 / 单源双向 z 可控性 / 点源 vs 平面源对比 / LIF Phase 1 梯度恢复力 + Hopfion 偏好低 Ku</a:t>
+            </a:r>
+          </a:p>
+          <a:p>
+            <a:pPr>
+              <a:defRPr sz="2000">
+                <a:solidFill>
+                  <a:srgbClr val="202020"/>
+                </a:solidFill>
+              </a:defRPr>
+            </a:pPr>
+          </a:p>
+          <a:p>
+            <a:pPr>
+              <a:defRPr sz="2000">
+                <a:solidFill>
+                  <a:srgbClr val="202020"/>
+                </a:solidFill>
+              </a:defRPr>
+            </a:pPr>
+            <a:r>
+              <a:t>跑完但未归纳完整结论：amplitude_sweep srcX 旧标度律已推翻、新拟合未确定 / freq_switch v3 反转成功但坍塌后无后续 / STT 复现仅趋势确认无定量扫描</a:t>
+            </a:r>
+          </a:p>
+          <a:p>
+            <a:pPr>
+              <a:defRPr sz="2000">
+                <a:solidFill>
+                  <a:srgbClr val="202020"/>
+                </a:solidFill>
+              </a:defRPr>
+            </a:pPr>
+          </a:p>
+          <a:p>
+            <a:pPr>
+              <a:defRPr sz="2000">
+                <a:solidFill>
+                  <a:srgbClr val="202020"/>
+                </a:solidFill>
+              </a:defRPr>
+            </a:pPr>
+            <a:r>
+              <a:t>停在半路：amplitude_sweep srcZ cron 部分缺失 / amplitude_sweep point B500 停在 0.433 ns / freq_switch v3 坍塌后未续 / LIF Phase 2 F1 在 1.089 ns kill</a:t>
+            </a:r>
+          </a:p>
+          <a:p>
+            <a:pPr>
+              <a:defRPr sz="2000">
+                <a:solidFill>
+                  <a:srgbClr val="202020"/>
+                </a:solidFill>
+              </a:defRPr>
+            </a:pPr>
+          </a:p>
+          <a:p>
+            <a:pPr>
+              <a:defRPr sz="2000">
+                <a:solidFill>
+                  <a:srgbClr val="202020"/>
+                </a:solidFill>
+              </a:defRPr>
+            </a:pPr>
+            <a:r>
+              <a:t>从未启动：Q_H=2 / Q_H=4 稳定性验证 / freq_switch v3 方案 A 调参 / LIF Phase 2 重设计 4 候选 / Wang 2019 STT 参数扫描深化</a:t>
+            </a:r>
+          </a:p>
+          <a:p>
+            <a:pPr>
+              <a:defRPr sz="2000">
+                <a:solidFill>
+                  <a:srgbClr val="202020"/>
+                </a:solidFill>
+              </a:defRPr>
+            </a:pPr>
+          </a:p>
+          <a:p>
+            <a:pPr>
+              <a:defRPr sz="2000">
                 <a:solidFill>
                   <a:srgbClr val="202020"/>
                 </a:solidFill>
@@ -7709,7 +7268,7 @@
           <a:lstStyle/>
           <a:p>
             <a:pPr>
-              <a:defRPr sz="2200" b="1">
+              <a:defRPr sz="2000" b="1">
                 <a:solidFill>
                   <a:srgbClr val="1F2D5A"/>
                 </a:solidFill>
@@ -7744,7 +7303,7 @@
           <a:lstStyle/>
           <a:p>
             <a:pPr>
-              <a:defRPr sz="1300">
+              <a:defRPr sz="2000">
                 <a:solidFill>
                   <a:srgbClr val="202020"/>
                 </a:solidFill>
@@ -7756,16 +7315,16 @@
           </a:p>
           <a:p>
             <a:pPr>
-              <a:defRPr sz="1300">
-                <a:solidFill>
-                  <a:srgbClr val="202020"/>
-                </a:solidFill>
-              </a:defRPr>
-            </a:pPr>
-          </a:p>
-          <a:p>
-            <a:pPr>
-              <a:defRPr sz="1300">
+              <a:defRPr sz="2000">
+                <a:solidFill>
+                  <a:srgbClr val="202020"/>
+                </a:solidFill>
+              </a:defRPr>
+            </a:pPr>
+          </a:p>
+          <a:p>
+            <a:pPr>
+              <a:defRPr sz="2000">
                 <a:solidFill>
                   <a:srgbClr val="202020"/>
                 </a:solidFill>
@@ -7777,16 +7336,16 @@
           </a:p>
           <a:p>
             <a:pPr>
-              <a:defRPr sz="1300">
-                <a:solidFill>
-                  <a:srgbClr val="202020"/>
-                </a:solidFill>
-              </a:defRPr>
-            </a:pPr>
-          </a:p>
-          <a:p>
-            <a:pPr>
-              <a:defRPr sz="1300">
+              <a:defRPr sz="2000">
+                <a:solidFill>
+                  <a:srgbClr val="202020"/>
+                </a:solidFill>
+              </a:defRPr>
+            </a:pPr>
+          </a:p>
+          <a:p>
+            <a:pPr>
+              <a:defRPr sz="2000">
                 <a:solidFill>
                   <a:srgbClr val="202020"/>
                 </a:solidFill>
@@ -7794,27 +7353,6 @@
             </a:pPr>
             <a:r>
               <a:t>无图。来源：`20251219_dmi_fm/failed_attempts/sutcliffe_disc_wrong_ansatz/`</a:t>
-            </a:r>
-          </a:p>
-          <a:p>
-            <a:pPr>
-              <a:defRPr sz="1300">
-                <a:solidFill>
-                  <a:srgbClr val="202020"/>
-                </a:solidFill>
-              </a:defRPr>
-            </a:pPr>
-          </a:p>
-          <a:p>
-            <a:pPr>
-              <a:defRPr sz="1300">
-                <a:solidFill>
-                  <a:srgbClr val="202020"/>
-                </a:solidFill>
-              </a:defRPr>
-            </a:pPr>
-            <a:r>
-              <a:t>---</a:t>
             </a:r>
           </a:p>
         </p:txBody>
@@ -7860,7 +7398,7 @@
           <a:lstStyle/>
           <a:p>
             <a:pPr>
-              <a:defRPr sz="2200" b="1">
+              <a:defRPr sz="2000" b="1">
                 <a:solidFill>
                   <a:srgbClr val="1F2D5A"/>
                 </a:solidFill>
@@ -7895,7 +7433,7 @@
           <a:lstStyle/>
           <a:p>
             <a:pPr>
-              <a:defRPr sz="1300">
+              <a:defRPr sz="2000">
                 <a:solidFill>
                   <a:srgbClr val="202020"/>
                 </a:solidFill>
@@ -7907,16 +7445,16 @@
           </a:p>
           <a:p>
             <a:pPr>
-              <a:defRPr sz="1300">
-                <a:solidFill>
-                  <a:srgbClr val="202020"/>
-                </a:solidFill>
-              </a:defRPr>
-            </a:pPr>
-          </a:p>
-          <a:p>
-            <a:pPr>
-              <a:defRPr sz="1300">
+              <a:defRPr sz="2000">
+                <a:solidFill>
+                  <a:srgbClr val="202020"/>
+                </a:solidFill>
+              </a:defRPr>
+            </a:pPr>
+          </a:p>
+          <a:p>
+            <a:pPr>
+              <a:defRPr sz="2000">
                 <a:solidFill>
                   <a:srgbClr val="202020"/>
                 </a:solidFill>
@@ -7924,27 +7462,6 @@
             </a:pPr>
             <a:r>
               <a:t>仅描述现象，无结论。来源：`20251219_dmi_fm/failed_attempts/toroidal_nanoring_approach/`</a:t>
-            </a:r>
-          </a:p>
-          <a:p>
-            <a:pPr>
-              <a:defRPr sz="1300">
-                <a:solidFill>
-                  <a:srgbClr val="202020"/>
-                </a:solidFill>
-              </a:defRPr>
-            </a:pPr>
-          </a:p>
-          <a:p>
-            <a:pPr>
-              <a:defRPr sz="1300">
-                <a:solidFill>
-                  <a:srgbClr val="202020"/>
-                </a:solidFill>
-              </a:defRPr>
-            </a:pPr>
-            <a:r>
-              <a:t>---</a:t>
             </a:r>
           </a:p>
         </p:txBody>
@@ -7990,7 +7507,7 @@
           <a:lstStyle/>
           <a:p>
             <a:pPr>
-              <a:defRPr sz="2200" b="1">
+              <a:defRPr sz="2000" b="1">
                 <a:solidFill>
                   <a:srgbClr val="1F2D5A"/>
                 </a:solidFill>
@@ -8025,7 +7542,7 @@
           <a:lstStyle/>
           <a:p>
             <a:pPr>
-              <a:defRPr sz="1300">
+              <a:defRPr sz="2000">
                 <a:solidFill>
                   <a:srgbClr val="202020"/>
                 </a:solidFill>
@@ -8037,16 +7554,16 @@
           </a:p>
           <a:p>
             <a:pPr>
-              <a:defRPr sz="1300">
-                <a:solidFill>
-                  <a:srgbClr val="202020"/>
-                </a:solidFill>
-              </a:defRPr>
-            </a:pPr>
-          </a:p>
-          <a:p>
-            <a:pPr>
-              <a:defRPr sz="1300">
+              <a:defRPr sz="2000">
+                <a:solidFill>
+                  <a:srgbClr val="202020"/>
+                </a:solidFill>
+              </a:defRPr>
+            </a:pPr>
+          </a:p>
+          <a:p>
+            <a:pPr>
+              <a:defRPr sz="2000">
                 <a:solidFill>
                   <a:srgbClr val="202020"/>
                 </a:solidFill>
@@ -8058,16 +7575,16 @@
           </a:p>
           <a:p>
             <a:pPr>
-              <a:defRPr sz="1300">
-                <a:solidFill>
-                  <a:srgbClr val="202020"/>
-                </a:solidFill>
-              </a:defRPr>
-            </a:pPr>
-          </a:p>
-          <a:p>
-            <a:pPr>
-              <a:defRPr sz="1300">
+              <a:defRPr sz="2000">
+                <a:solidFill>
+                  <a:srgbClr val="202020"/>
+                </a:solidFill>
+              </a:defRPr>
+            </a:pPr>
+          </a:p>
+          <a:p>
+            <a:pPr>
+              <a:defRPr sz="2000">
                 <a:solidFill>
                   <a:srgbClr val="202020"/>
                 </a:solidFill>
@@ -8075,27 +7592,6 @@
             </a:pPr>
             <a:r>
               <a:t>无图。来源：`20251219_dmi_fm/{isolated_hopfion_10lambda, neel_hopfion}/`</a:t>
-            </a:r>
-          </a:p>
-          <a:p>
-            <a:pPr>
-              <a:defRPr sz="1300">
-                <a:solidFill>
-                  <a:srgbClr val="202020"/>
-                </a:solidFill>
-              </a:defRPr>
-            </a:pPr>
-          </a:p>
-          <a:p>
-            <a:pPr>
-              <a:defRPr sz="1300">
-                <a:solidFill>
-                  <a:srgbClr val="202020"/>
-                </a:solidFill>
-              </a:defRPr>
-            </a:pPr>
-            <a:r>
-              <a:t>---</a:t>
             </a:r>
           </a:p>
         </p:txBody>
@@ -8141,7 +7637,7 @@
           <a:lstStyle/>
           <a:p>
             <a:pPr>
-              <a:defRPr sz="2200" b="1">
+              <a:defRPr sz="2000" b="1">
                 <a:solidFill>
                   <a:srgbClr val="1F2D5A"/>
                 </a:solidFill>
@@ -8176,7 +7672,7 @@
           <a:lstStyle/>
           <a:p>
             <a:pPr>
-              <a:defRPr sz="1300">
+              <a:defRPr sz="2000">
                 <a:solidFill>
                   <a:srgbClr val="202020"/>
                 </a:solidFill>
@@ -8188,16 +7684,16 @@
           </a:p>
           <a:p>
             <a:pPr>
-              <a:defRPr sz="1300">
-                <a:solidFill>
-                  <a:srgbClr val="202020"/>
-                </a:solidFill>
-              </a:defRPr>
-            </a:pPr>
-          </a:p>
-          <a:p>
-            <a:pPr>
-              <a:defRPr sz="1300">
+              <a:defRPr sz="2000">
+                <a:solidFill>
+                  <a:srgbClr val="202020"/>
+                </a:solidFill>
+              </a:defRPr>
+            </a:pPr>
+          </a:p>
+          <a:p>
+            <a:pPr>
+              <a:defRPr sz="2000">
                 <a:solidFill>
                   <a:srgbClr val="202020"/>
                 </a:solidFill>
@@ -8209,16 +7705,16 @@
           </a:p>
           <a:p>
             <a:pPr>
-              <a:defRPr sz="1300">
-                <a:solidFill>
-                  <a:srgbClr val="202020"/>
-                </a:solidFill>
-              </a:defRPr>
-            </a:pPr>
-          </a:p>
-          <a:p>
-            <a:pPr>
-              <a:defRPr sz="1300">
+              <a:defRPr sz="2000">
+                <a:solidFill>
+                  <a:srgbClr val="202020"/>
+                </a:solidFill>
+              </a:defRPr>
+            </a:pPr>
+          </a:p>
+          <a:p>
+            <a:pPr>
+              <a:defRPr sz="2000">
                 <a:solidFill>
                   <a:srgbClr val="202020"/>
                 </a:solidFill>
@@ -8226,27 +7722,6 @@
             </a:pPr>
             <a:r>
               <a:t>无图（可加 bishe fig3-3_size_convergence）。来源：`20260105_frustrated_fm/size_sweep/`</a:t>
-            </a:r>
-          </a:p>
-          <a:p>
-            <a:pPr>
-              <a:defRPr sz="1300">
-                <a:solidFill>
-                  <a:srgbClr val="202020"/>
-                </a:solidFill>
-              </a:defRPr>
-            </a:pPr>
-          </a:p>
-          <a:p>
-            <a:pPr>
-              <a:defRPr sz="1300">
-                <a:solidFill>
-                  <a:srgbClr val="202020"/>
-                </a:solidFill>
-              </a:defRPr>
-            </a:pPr>
-            <a:r>
-              <a:t>---</a:t>
             </a:r>
           </a:p>
         </p:txBody>
@@ -8292,7 +7767,7 @@
           <a:lstStyle/>
           <a:p>
             <a:pPr>
-              <a:defRPr sz="2200" b="1">
+              <a:defRPr sz="2000" b="1">
                 <a:solidFill>
                   <a:srgbClr val="1F2D5A"/>
                 </a:solidFill>
@@ -8327,7 +7802,7 @@
           <a:lstStyle/>
           <a:p>
             <a:pPr>
-              <a:defRPr sz="1300">
+              <a:defRPr sz="2000">
                 <a:solidFill>
                   <a:srgbClr val="202020"/>
                 </a:solidFill>
@@ -8339,16 +7814,16 @@
           </a:p>
           <a:p>
             <a:pPr>
-              <a:defRPr sz="1300">
-                <a:solidFill>
-                  <a:srgbClr val="202020"/>
-                </a:solidFill>
-              </a:defRPr>
-            </a:pPr>
-          </a:p>
-          <a:p>
-            <a:pPr>
-              <a:defRPr sz="1300">
+              <a:defRPr sz="2000">
+                <a:solidFill>
+                  <a:srgbClr val="202020"/>
+                </a:solidFill>
+              </a:defRPr>
+            </a:pPr>
+          </a:p>
+          <a:p>
+            <a:pPr>
+              <a:defRPr sz="2000">
                 <a:solidFill>
                   <a:srgbClr val="202020"/>
                 </a:solidFill>
@@ -8360,7 +7835,7 @@
           </a:p>
           <a:p>
             <a:pPr>
-              <a:defRPr sz="1300">
+              <a:defRPr sz="2000">
                 <a:solidFill>
                   <a:srgbClr val="202020"/>
                 </a:solidFill>
@@ -8372,7 +7847,7 @@
           </a:p>
           <a:p>
             <a:pPr>
-              <a:defRPr sz="1300">
+              <a:defRPr sz="2000">
                 <a:solidFill>
                   <a:srgbClr val="202020"/>
                 </a:solidFill>
@@ -8384,7 +7859,7 @@
           </a:p>
           <a:p>
             <a:pPr>
-              <a:defRPr sz="1300">
+              <a:defRPr sz="2000">
                 <a:solidFill>
                   <a:srgbClr val="202020"/>
                 </a:solidFill>
@@ -8396,7 +7871,7 @@
           </a:p>
           <a:p>
             <a:pPr>
-              <a:defRPr sz="1300">
+              <a:defRPr sz="2000">
                 <a:solidFill>
                   <a:srgbClr val="202020"/>
                 </a:solidFill>
@@ -8408,16 +7883,16 @@
           </a:p>
           <a:p>
             <a:pPr>
-              <a:defRPr sz="1300">
-                <a:solidFill>
-                  <a:srgbClr val="202020"/>
-                </a:solidFill>
-              </a:defRPr>
-            </a:pPr>
-          </a:p>
-          <a:p>
-            <a:pPr>
-              <a:defRPr sz="1300">
+              <a:defRPr sz="2000">
+                <a:solidFill>
+                  <a:srgbClr val="202020"/>
+                </a:solidFill>
+              </a:defRPr>
+            </a:pPr>
+          </a:p>
+          <a:p>
+            <a:pPr>
+              <a:defRPr sz="2000">
                 <a:solidFill>
                   <a:srgbClr val="202020"/>
                 </a:solidFill>
@@ -8429,16 +7904,16 @@
           </a:p>
           <a:p>
             <a:pPr>
-              <a:defRPr sz="1300">
-                <a:solidFill>
-                  <a:srgbClr val="202020"/>
-                </a:solidFill>
-              </a:defRPr>
-            </a:pPr>
-          </a:p>
-          <a:p>
-            <a:pPr>
-              <a:defRPr sz="1300">
+              <a:defRPr sz="2000">
+                <a:solidFill>
+                  <a:srgbClr val="202020"/>
+                </a:solidFill>
+              </a:defRPr>
+            </a:pPr>
+          </a:p>
+          <a:p>
+            <a:pPr>
+              <a:defRPr sz="2000">
                 <a:solidFill>
                   <a:srgbClr val="202020"/>
                 </a:solidFill>
@@ -8446,27 +7921,6 @@
             </a:pPr>
             <a:r>
               <a:t>无图。来源：`20260105_frustrated_fm/centered_stability_test/`</a:t>
-            </a:r>
-          </a:p>
-          <a:p>
-            <a:pPr>
-              <a:defRPr sz="1300">
-                <a:solidFill>
-                  <a:srgbClr val="202020"/>
-                </a:solidFill>
-              </a:defRPr>
-            </a:pPr>
-          </a:p>
-          <a:p>
-            <a:pPr>
-              <a:defRPr sz="1300">
-                <a:solidFill>
-                  <a:srgbClr val="202020"/>
-                </a:solidFill>
-              </a:defRPr>
-            </a:pPr>
-            <a:r>
-              <a:t>---</a:t>
             </a:r>
           </a:p>
         </p:txBody>
@@ -8512,7 +7966,7 @@
           <a:lstStyle/>
           <a:p>
             <a:pPr>
-              <a:defRPr sz="2200" b="1">
+              <a:defRPr sz="2000" b="1">
                 <a:solidFill>
                   <a:srgbClr val="1F2D5A"/>
                 </a:solidFill>
@@ -8547,7 +8001,7 @@
           <a:lstStyle/>
           <a:p>
             <a:pPr>
-              <a:defRPr sz="1300">
+              <a:defRPr sz="2000">
                 <a:solidFill>
                   <a:srgbClr val="202020"/>
                 </a:solidFill>
@@ -8559,16 +8013,16 @@
           </a:p>
           <a:p>
             <a:pPr>
-              <a:defRPr sz="1300">
-                <a:solidFill>
-                  <a:srgbClr val="202020"/>
-                </a:solidFill>
-              </a:defRPr>
-            </a:pPr>
-          </a:p>
-          <a:p>
-            <a:pPr>
-              <a:defRPr sz="1300">
+              <a:defRPr sz="2000">
+                <a:solidFill>
+                  <a:srgbClr val="202020"/>
+                </a:solidFill>
+              </a:defRPr>
+            </a:pPr>
+          </a:p>
+          <a:p>
+            <a:pPr>
+              <a:defRPr sz="2000">
                 <a:solidFill>
                   <a:srgbClr val="202020"/>
                 </a:solidFill>
@@ -8580,16 +8034,16 @@
           </a:p>
           <a:p>
             <a:pPr>
-              <a:defRPr sz="1300">
-                <a:solidFill>
-                  <a:srgbClr val="202020"/>
-                </a:solidFill>
-              </a:defRPr>
-            </a:pPr>
-          </a:p>
-          <a:p>
-            <a:pPr>
-              <a:defRPr sz="1300">
+              <a:defRPr sz="2000">
+                <a:solidFill>
+                  <a:srgbClr val="202020"/>
+                </a:solidFill>
+              </a:defRPr>
+            </a:pPr>
+          </a:p>
+          <a:p>
+            <a:pPr>
+              <a:defRPr sz="2000">
                 <a:solidFill>
                   <a:srgbClr val="202020"/>
                 </a:solidFill>
@@ -8597,27 +8051,6 @@
             </a:pPr>
             <a:r>
               <a:t>来源：`20260105_frustrated_fm/anisotropy_study/ku_critical_sweep/`</a:t>
-            </a:r>
-          </a:p>
-          <a:p>
-            <a:pPr>
-              <a:defRPr sz="1300">
-                <a:solidFill>
-                  <a:srgbClr val="202020"/>
-                </a:solidFill>
-              </a:defRPr>
-            </a:pPr>
-          </a:p>
-          <a:p>
-            <a:pPr>
-              <a:defRPr sz="1300">
-                <a:solidFill>
-                  <a:srgbClr val="202020"/>
-                </a:solidFill>
-              </a:defRPr>
-            </a:pPr>
-            <a:r>
-              <a:t>---</a:t>
             </a:r>
           </a:p>
         </p:txBody>
@@ -8687,7 +8120,7 @@
           <a:lstStyle/>
           <a:p>
             <a:pPr>
-              <a:defRPr sz="2200" b="1">
+              <a:defRPr sz="2000" b="1">
                 <a:solidFill>
                   <a:srgbClr val="1F2D5A"/>
                 </a:solidFill>
@@ -8722,7 +8155,7 @@
           <a:lstStyle/>
           <a:p>
             <a:pPr>
-              <a:defRPr sz="1300">
+              <a:defRPr sz="2000">
                 <a:solidFill>
                   <a:srgbClr val="202020"/>
                 </a:solidFill>
@@ -8734,37 +8167,37 @@
           </a:p>
           <a:p>
             <a:pPr>
-              <a:defRPr sz="1300">
-                <a:solidFill>
-                  <a:srgbClr val="202020"/>
-                </a:solidFill>
-              </a:defRPr>
-            </a:pPr>
-          </a:p>
-          <a:p>
-            <a:pPr>
-              <a:defRPr sz="1300">
-                <a:solidFill>
-                  <a:srgbClr val="202020"/>
-                </a:solidFill>
-              </a:defRPr>
-            </a:pPr>
-            <a:r>
-              <a:t>compute_hopf_index.py 对当前体系所有 Hopfion 初始态做 Q_H 数值验证：结果均为 Q_H=1。Q_H=2 (p=1,q=2) 和 Q_H=4 在 frustrated FM 体系下的稳定性**从未仿真**，是下一步方向。</a:t>
-            </a:r>
-          </a:p>
-          <a:p>
-            <a:pPr>
-              <a:defRPr sz="1300">
-                <a:solidFill>
-                  <a:srgbClr val="202020"/>
-                </a:solidFill>
-              </a:defRPr>
-            </a:pPr>
-          </a:p>
-          <a:p>
-            <a:pPr>
-              <a:defRPr sz="1300">
+              <a:defRPr sz="2000">
+                <a:solidFill>
+                  <a:srgbClr val="202020"/>
+                </a:solidFill>
+              </a:defRPr>
+            </a:pPr>
+          </a:p>
+          <a:p>
+            <a:pPr>
+              <a:defRPr sz="2000">
+                <a:solidFill>
+                  <a:srgbClr val="202020"/>
+                </a:solidFill>
+              </a:defRPr>
+            </a:pPr>
+            <a:r>
+              <a:t>compute_hopf_index.py 对当前体系所有 Hopfion 初始态做 Q_H 数值验证：结果均为 Q_H=1。Q_H=2 (p=1,q=2) 和 Q_H=4 在 frustrated FM 体系下的稳定性从未仿真，是下一步方向。</a:t>
+            </a:r>
+          </a:p>
+          <a:p>
+            <a:pPr>
+              <a:defRPr sz="2000">
+                <a:solidFill>
+                  <a:srgbClr val="202020"/>
+                </a:solidFill>
+              </a:defRPr>
+            </a:pPr>
+          </a:p>
+          <a:p>
+            <a:pPr>
+              <a:defRPr sz="2000">
                 <a:solidFill>
                   <a:srgbClr val="202020"/>
                 </a:solidFill>
@@ -8772,27 +8205,6 @@
             </a:pPr>
             <a:r>
               <a:t>无图。来源：`20260105_frustrated_fm/anisotropy_study/size_vs_ku/` + `compute_hopf_index.py`</a:t>
-            </a:r>
-          </a:p>
-          <a:p>
-            <a:pPr>
-              <a:defRPr sz="1300">
-                <a:solidFill>
-                  <a:srgbClr val="202020"/>
-                </a:solidFill>
-              </a:defRPr>
-            </a:pPr>
-          </a:p>
-          <a:p>
-            <a:pPr>
-              <a:defRPr sz="1300">
-                <a:solidFill>
-                  <a:srgbClr val="202020"/>
-                </a:solidFill>
-              </a:defRPr>
-            </a:pPr>
-            <a:r>
-              <a:t>---</a:t>
             </a:r>
           </a:p>
         </p:txBody>

</xml_diff>